<commit_message>
docs(deck): brand mark on the cover and in every footer
Co-Authored-By: Claude Opus 5 (1M context) <noreply@anthropic.com>
</commit_message>
<xml_diff>
--- a/app/public/pitch-deck.pptx
+++ b/app/public/pitch-deck.pptx
@@ -7308,8 +7308,8 @@
         </p:nvSpPr>
         <p:spPr>
           <a:xfrm>
-            <a:off x="566928" y="3675888"/>
-            <a:ext cx="5852160" cy="868680"/>
+            <a:off x="1261872" y="3675888"/>
+            <a:ext cx="5212080" cy="868680"/>
           </a:xfrm>
           <a:prstGeom prst="rect">
             <a:avLst/>
@@ -7404,6 +7404,31 @@
           </a:p>
         </p:txBody>
       </p:sp>
+      <p:pic>
+        <p:nvPicPr>
+          <p:cNvPr id="901" name="pic901"/>
+          <p:cNvPicPr preferRelativeResize="0"/>
+          <p:nvPr/>
+        </p:nvPicPr>
+        <p:blipFill>
+          <a:blip r:embed="rIdLogo"/>
+          <a:stretch>
+            <a:fillRect/>
+          </a:stretch>
+        </p:blipFill>
+        <p:spPr>
+          <a:xfrm>
+            <a:off x="566928" y="3712464"/>
+            <a:ext cx="566928" cy="566928"/>
+          </a:xfrm>
+          <a:prstGeom prst="rect">
+            <a:avLst/>
+          </a:prstGeom>
+          <a:ln>
+            <a:noFill/>
+          </a:ln>
+        </p:spPr>
+      </p:pic>
     </p:spTree>
   </p:cSld>
   <p:clrMapOvr>
@@ -8172,13 +8197,13 @@
       </p:sp>
       <p:sp>
         <p:nvSpPr>
-          <p:cNvPr id="31" name="tb31"/>
+          <p:cNvPr id="32" name="tb32"/>
           <p:cNvSpPr txBox="1"/>
           <p:nvPr/>
         </p:nvSpPr>
         <p:spPr>
           <a:xfrm>
-            <a:off x="566928" y="4690872"/>
+            <a:off x="804672" y="4690872"/>
             <a:ext cx="2743200" cy="182880"/>
           </a:xfrm>
           <a:prstGeom prst="rect">
@@ -8224,7 +8249,7 @@
       </p:sp>
       <p:sp>
         <p:nvSpPr>
-          <p:cNvPr id="32" name="tb32"/>
+          <p:cNvPr id="33" name="tb33"/>
           <p:cNvSpPr txBox="1"/>
           <p:nvPr/>
         </p:nvSpPr>
@@ -8274,6 +8299,31 @@
           </a:p>
         </p:txBody>
       </p:sp>
+      <p:pic>
+        <p:nvPicPr>
+          <p:cNvPr id="31" name="pic31"/>
+          <p:cNvPicPr preferRelativeResize="0"/>
+          <p:nvPr/>
+        </p:nvPicPr>
+        <p:blipFill>
+          <a:blip r:embed="rId2"/>
+          <a:stretch>
+            <a:fillRect/>
+          </a:stretch>
+        </p:blipFill>
+        <p:spPr>
+          <a:xfrm>
+            <a:off x="566928" y="4645152"/>
+            <a:ext cx="173736" cy="173736"/>
+          </a:xfrm>
+          <a:prstGeom prst="rect">
+            <a:avLst/>
+          </a:prstGeom>
+          <a:ln>
+            <a:noFill/>
+          </a:ln>
+        </p:spPr>
+      </p:pic>
     </p:spTree>
   </p:cSld>
   <p:clrMapOvr>
@@ -9744,13 +9794,13 @@
       </p:sp>
       <p:sp>
         <p:nvSpPr>
-          <p:cNvPr id="46" name="tb46"/>
+          <p:cNvPr id="47" name="tb47"/>
           <p:cNvSpPr txBox="1"/>
           <p:nvPr/>
         </p:nvSpPr>
         <p:spPr>
           <a:xfrm>
-            <a:off x="566928" y="4690872"/>
+            <a:off x="804672" y="4690872"/>
             <a:ext cx="2743200" cy="182880"/>
           </a:xfrm>
           <a:prstGeom prst="rect">
@@ -9796,7 +9846,7 @@
       </p:sp>
       <p:sp>
         <p:nvSpPr>
-          <p:cNvPr id="47" name="tb47"/>
+          <p:cNvPr id="48" name="tb48"/>
           <p:cNvSpPr txBox="1"/>
           <p:nvPr/>
         </p:nvSpPr>
@@ -9846,6 +9896,31 @@
           </a:p>
         </p:txBody>
       </p:sp>
+      <p:pic>
+        <p:nvPicPr>
+          <p:cNvPr id="46" name="pic46"/>
+          <p:cNvPicPr preferRelativeResize="0"/>
+          <p:nvPr/>
+        </p:nvPicPr>
+        <p:blipFill>
+          <a:blip r:embed="rId2"/>
+          <a:stretch>
+            <a:fillRect/>
+          </a:stretch>
+        </p:blipFill>
+        <p:spPr>
+          <a:xfrm>
+            <a:off x="566928" y="4645152"/>
+            <a:ext cx="173736" cy="173736"/>
+          </a:xfrm>
+          <a:prstGeom prst="rect">
+            <a:avLst/>
+          </a:prstGeom>
+          <a:ln>
+            <a:noFill/>
+          </a:ln>
+        </p:spPr>
+      </p:pic>
     </p:spTree>
   </p:cSld>
   <p:clrMapOvr>
@@ -10652,13 +10727,13 @@
       </p:sp>
       <p:sp>
         <p:nvSpPr>
-          <p:cNvPr id="37" name="tb37"/>
+          <p:cNvPr id="38" name="tb38"/>
           <p:cNvSpPr txBox="1"/>
           <p:nvPr/>
         </p:nvSpPr>
         <p:spPr>
           <a:xfrm>
-            <a:off x="566928" y="4690872"/>
+            <a:off x="804672" y="4690872"/>
             <a:ext cx="2743200" cy="182880"/>
           </a:xfrm>
           <a:prstGeom prst="rect">
@@ -10704,7 +10779,7 @@
       </p:sp>
       <p:sp>
         <p:nvSpPr>
-          <p:cNvPr id="38" name="tb38"/>
+          <p:cNvPr id="39" name="tb39"/>
           <p:cNvSpPr txBox="1"/>
           <p:nvPr/>
         </p:nvSpPr>
@@ -10824,6 +10899,31 @@
               </a:srgbClr>
             </a:outerShdw>
           </a:effectLst>
+        </p:spPr>
+      </p:pic>
+      <p:pic>
+        <p:nvPicPr>
+          <p:cNvPr id="37" name="pic37"/>
+          <p:cNvPicPr preferRelativeResize="0"/>
+          <p:nvPr/>
+        </p:nvPicPr>
+        <p:blipFill>
+          <a:blip r:embed="rId4"/>
+          <a:stretch>
+            <a:fillRect/>
+          </a:stretch>
+        </p:blipFill>
+        <p:spPr>
+          <a:xfrm>
+            <a:off x="566928" y="4645152"/>
+            <a:ext cx="173736" cy="173736"/>
+          </a:xfrm>
+          <a:prstGeom prst="rect">
+            <a:avLst/>
+          </a:prstGeom>
+          <a:ln>
+            <a:noFill/>
+          </a:ln>
         </p:spPr>
       </p:pic>
     </p:spTree>
@@ -12330,13 +12430,13 @@
       </p:sp>
       <p:sp>
         <p:nvSpPr>
-          <p:cNvPr id="48" name="tb48"/>
+          <p:cNvPr id="49" name="tb49"/>
           <p:cNvSpPr txBox="1"/>
           <p:nvPr/>
         </p:nvSpPr>
         <p:spPr>
           <a:xfrm>
-            <a:off x="566928" y="4690872"/>
+            <a:off x="804672" y="4690872"/>
             <a:ext cx="2743200" cy="182880"/>
           </a:xfrm>
           <a:prstGeom prst="rect">
@@ -12382,7 +12482,7 @@
       </p:sp>
       <p:sp>
         <p:nvSpPr>
-          <p:cNvPr id="49" name="tb49"/>
+          <p:cNvPr id="50" name="tb50"/>
           <p:cNvSpPr txBox="1"/>
           <p:nvPr/>
         </p:nvSpPr>
@@ -12432,6 +12532,31 @@
           </a:p>
         </p:txBody>
       </p:sp>
+      <p:pic>
+        <p:nvPicPr>
+          <p:cNvPr id="48" name="pic48"/>
+          <p:cNvPicPr preferRelativeResize="0"/>
+          <p:nvPr/>
+        </p:nvPicPr>
+        <p:blipFill>
+          <a:blip r:embed="rId2"/>
+          <a:stretch>
+            <a:fillRect/>
+          </a:stretch>
+        </p:blipFill>
+        <p:spPr>
+          <a:xfrm>
+            <a:off x="566928" y="4645152"/>
+            <a:ext cx="173736" cy="173736"/>
+          </a:xfrm>
+          <a:prstGeom prst="rect">
+            <a:avLst/>
+          </a:prstGeom>
+          <a:ln>
+            <a:noFill/>
+          </a:ln>
+        </p:spPr>
+      </p:pic>
     </p:spTree>
   </p:cSld>
   <p:clrMapOvr>
@@ -13574,13 +13699,13 @@
       </p:sp>
       <p:sp>
         <p:nvSpPr>
-          <p:cNvPr id="41" name="tb41"/>
+          <p:cNvPr id="42" name="tb42"/>
           <p:cNvSpPr txBox="1"/>
           <p:nvPr/>
         </p:nvSpPr>
         <p:spPr>
           <a:xfrm>
-            <a:off x="566928" y="4690872"/>
+            <a:off x="804672" y="4690872"/>
             <a:ext cx="2743200" cy="182880"/>
           </a:xfrm>
           <a:prstGeom prst="rect">
@@ -13626,7 +13751,7 @@
       </p:sp>
       <p:sp>
         <p:nvSpPr>
-          <p:cNvPr id="42" name="tb42"/>
+          <p:cNvPr id="43" name="tb43"/>
           <p:cNvSpPr txBox="1"/>
           <p:nvPr/>
         </p:nvSpPr>
@@ -13676,6 +13801,31 @@
           </a:p>
         </p:txBody>
       </p:sp>
+      <p:pic>
+        <p:nvPicPr>
+          <p:cNvPr id="41" name="pic41"/>
+          <p:cNvPicPr preferRelativeResize="0"/>
+          <p:nvPr/>
+        </p:nvPicPr>
+        <p:blipFill>
+          <a:blip r:embed="rId2"/>
+          <a:stretch>
+            <a:fillRect/>
+          </a:stretch>
+        </p:blipFill>
+        <p:spPr>
+          <a:xfrm>
+            <a:off x="566928" y="4645152"/>
+            <a:ext cx="173736" cy="173736"/>
+          </a:xfrm>
+          <a:prstGeom prst="rect">
+            <a:avLst/>
+          </a:prstGeom>
+          <a:ln>
+            <a:noFill/>
+          </a:ln>
+        </p:spPr>
+      </p:pic>
     </p:spTree>
   </p:cSld>
   <p:clrMapOvr>
@@ -15066,13 +15216,13 @@
       </p:sp>
       <p:sp>
         <p:nvSpPr>
-          <p:cNvPr id="46" name="tb46"/>
+          <p:cNvPr id="47" name="tb47"/>
           <p:cNvSpPr txBox="1"/>
           <p:nvPr/>
         </p:nvSpPr>
         <p:spPr>
           <a:xfrm>
-            <a:off x="566928" y="4690872"/>
+            <a:off x="804672" y="4690872"/>
             <a:ext cx="2743200" cy="182880"/>
           </a:xfrm>
           <a:prstGeom prst="rect">
@@ -15118,7 +15268,7 @@
       </p:sp>
       <p:sp>
         <p:nvSpPr>
-          <p:cNvPr id="47" name="tb47"/>
+          <p:cNvPr id="48" name="tb48"/>
           <p:cNvSpPr txBox="1"/>
           <p:nvPr/>
         </p:nvSpPr>
@@ -15168,6 +15318,31 @@
           </a:p>
         </p:txBody>
       </p:sp>
+      <p:pic>
+        <p:nvPicPr>
+          <p:cNvPr id="46" name="pic46"/>
+          <p:cNvPicPr preferRelativeResize="0"/>
+          <p:nvPr/>
+        </p:nvPicPr>
+        <p:blipFill>
+          <a:blip r:embed="rId2"/>
+          <a:stretch>
+            <a:fillRect/>
+          </a:stretch>
+        </p:blipFill>
+        <p:spPr>
+          <a:xfrm>
+            <a:off x="566928" y="4645152"/>
+            <a:ext cx="173736" cy="173736"/>
+          </a:xfrm>
+          <a:prstGeom prst="rect">
+            <a:avLst/>
+          </a:prstGeom>
+          <a:ln>
+            <a:noFill/>
+          </a:ln>
+        </p:spPr>
+      </p:pic>
     </p:spTree>
   </p:cSld>
   <p:clrMapOvr>

</xml_diff>

<commit_message>
docs: answer the submission criteria point by point
The criteria ask the README to cover design decisions with their trade-offs
and the technical challenges we hit, as named sections; both existed only
scattered through the text. Adds them as tables, so a judge reading top to
bottom finds them where they are expected.

The Mermaid diagram gains the three real paths it was missing: permissionless
refund, reputation derived from contract events, and the external models the
judges and NEXUS call.

'Why mainnet, not testnet' now makes the argument properly instead of
apologising for it, and the hackathon block states it in the first two lines.
The deck carries the same line where the evidence is, and The Team goes back
to its own slide so the template's sections stay one to a slide.

Co-Authored-By: Claude Opus 5 (1M context) <noreply@anthropic.com>
</commit_message>
<xml_diff>
--- a/app/public/pitch-deck.pptx
+++ b/app/public/pitch-deck.pptx
@@ -16,6 +16,7 @@
     <p:sldId id="260" r:id="rIdSlide5"/>
     <p:sldId id="261" r:id="rIdSlide6"/>
     <p:sldId id="262" r:id="rIdSlide7"/>
+    <p:sldId id="263" r:id="rIdSlide8"/>
   </p:sldIdLst>
   <p:sldSz cy="5143500" cx="9144000"/>
   <p:notesSz cx="6858000" cy="9144000"/>
@@ -8294,7 +8295,7 @@
                 <a:cs typeface="Courier New"/>
                 <a:sym typeface="Courier New"/>
               </a:rPr>
-              <a:t>2 / 7</a:t>
+              <a:t>2 / 8</a:t>
             </a:r>
           </a:p>
         </p:txBody>
@@ -9891,7 +9892,7 @@
                 <a:cs typeface="Courier New"/>
                 <a:sym typeface="Courier New"/>
               </a:rPr>
-              <a:t>3 / 7</a:t>
+              <a:t>3 / 8</a:t>
             </a:r>
           </a:p>
         </p:txBody>
@@ -10824,7 +10825,7 @@
                 <a:cs typeface="Courier New"/>
                 <a:sym typeface="Courier New"/>
               </a:rPr>
-              <a:t>4 / 7</a:t>
+              <a:t>4 / 8</a:t>
             </a:r>
           </a:p>
         </p:txBody>
@@ -12385,7 +12386,7 @@
         <p:spPr>
           <a:xfrm>
             <a:off x="5120640" y="3520440"/>
-            <a:ext cx="3474720" cy="1005840"/>
+            <a:ext cx="3474720" cy="685800"/>
           </a:xfrm>
           <a:prstGeom prst="rect">
             <a:avLst/>
@@ -12423,14 +12424,116 @@
                 <a:cs typeface="Georgia"/>
                 <a:sym typeface="Georgia"/>
               </a:rPr>
-              <a:t>Reputation and market stats are derived from the escrow's own events under a published rule, so anyone in the room can run that command and get the same answer. Nothing comes from my database, and no platform wallet sits anywhere in the payout path.</a:t>
-            </a:r>
-          </a:p>
+              <a:t>Derived from the escrow's own events under a published rule, so anyone in the room gets the same answer. Nothing comes from my database, and no platform wallet sits in the payout path.</a:t>
+            </a:r>
+          </a:p>
+        </p:txBody>
+      </p:sp>
+      <p:sp>
+        <p:nvSpPr>
+          <p:cNvPr id="48" name="panel48"/>
+          <p:cNvSpPr/>
+          <p:nvPr/>
+        </p:nvSpPr>
+        <p:spPr>
+          <a:xfrm>
+            <a:off x="5120640" y="4224528"/>
+            <a:ext cx="3456432" cy="384048"/>
+          </a:xfrm>
+          <a:prstGeom prst="roundRect">
+            <a:avLst>
+              <a:gd name="adj" fmla="val 6000"/>
+            </a:avLst>
+          </a:prstGeom>
+          <a:solidFill>
+            <a:srgbClr val="0F1A12"/>
+          </a:solidFill>
+          <a:ln w="9525">
+            <a:solidFill>
+              <a:srgbClr val="3A2A18"/>
+            </a:solidFill>
+          </a:ln>
+          <a:effectLst>
+            <a:outerShdw blurRad="180000" dist="45000" dir="5400000" rotWithShape="0">
+              <a:srgbClr val="000000">
+                <a:alpha val="48000"/>
+              </a:srgbClr>
+            </a:outerShdw>
+          </a:effectLst>
+        </p:spPr>
+        <p:txBody>
+          <a:bodyPr/>
+          <a:lstStyle/>
+          <a:p/>
         </p:txBody>
       </p:sp>
       <p:sp>
         <p:nvSpPr>
           <p:cNvPr id="49" name="tb49"/>
+          <p:cNvSpPr txBox="1"/>
+          <p:nvPr/>
+        </p:nvSpPr>
+        <p:spPr>
+          <a:xfrm>
+            <a:off x="5303520" y="4315968"/>
+            <a:ext cx="3108960" cy="228600"/>
+          </a:xfrm>
+          <a:prstGeom prst="rect">
+            <a:avLst/>
+          </a:prstGeom>
+          <a:noFill/>
+          <a:ln>
+            <a:noFill/>
+          </a:ln>
+        </p:spPr>
+        <p:txBody>
+          <a:bodyPr anchorCtr="0" anchor="t" bIns="0" lIns="0" rIns="0" tIns="0" wrap="square" spcFirstLastPara="1">
+            <a:noAutofit/>
+          </a:bodyPr>
+          <a:lstStyle/>
+          <a:p>
+            <a:pPr indent="0" lvl="0" marL="0" rtl="0" algn="l">
+              <a:lnSpc>
+                <a:spcPct val="120000"/>
+              </a:lnSpc>
+              <a:spcBef>
+                <a:spcPts val="0"/>
+              </a:spcBef>
+              <a:spcAft>
+                <a:spcPts val="0"/>
+              </a:spcAft>
+              <a:buNone/>
+            </a:pPr>
+            <a:r>
+              <a:rPr lang="en" sz="850" b="1" i="0">
+                <a:solidFill>
+                  <a:srgbClr val="7FD6A0"/>
+                </a:solidFill>
+                <a:latin typeface="Courier New"/>
+                <a:ea typeface="Courier New"/>
+                <a:cs typeface="Courier New"/>
+                <a:sym typeface="Courier New"/>
+              </a:rPr>
+              <a:t>MAINNET, NOT TESTNET</a:t>
+            </a:r>
+            <a:r>
+              <a:rPr lang="en" sz="850" b="0" i="0">
+                <a:solidFill>
+                  <a:srgbClr val="C9B994"/>
+                </a:solidFill>
+                <a:latin typeface="Courier New"/>
+                <a:ea typeface="Courier New"/>
+                <a:cs typeface="Courier New"/>
+                <a:sym typeface="Courier New"/>
+              </a:rPr>
+              <a:t>   same code, real funds</a:t>
+            </a:r>
+          </a:p>
+        </p:txBody>
+      </p:sp>
+      <p:sp>
+        <p:nvSpPr>
+          <p:cNvPr id="51" name="tb51"/>
           <p:cNvSpPr txBox="1"/>
           <p:nvPr/>
         </p:nvSpPr>
@@ -12482,7 +12585,7 @@
       </p:sp>
       <p:sp>
         <p:nvSpPr>
-          <p:cNvPr id="50" name="tb50"/>
+          <p:cNvPr id="52" name="tb52"/>
           <p:cNvSpPr txBox="1"/>
           <p:nvPr/>
         </p:nvSpPr>
@@ -12527,14 +12630,14 @@
                 <a:cs typeface="Courier New"/>
                 <a:sym typeface="Courier New"/>
               </a:rPr>
-              <a:t>5 / 7</a:t>
+              <a:t>5 / 8</a:t>
             </a:r>
           </a:p>
         </p:txBody>
       </p:sp>
       <p:pic>
         <p:nvPicPr>
-          <p:cNvPr id="48" name="pic48"/>
+          <p:cNvPr id="50" name="pic50"/>
           <p:cNvPicPr preferRelativeResize="0"/>
           <p:nvPr/>
         </p:nvPicPr>
@@ -13796,7 +13899,7 @@
                 <a:cs typeface="Courier New"/>
                 <a:sym typeface="Courier New"/>
               </a:rPr>
-              <a:t>6 / 7</a:t>
+              <a:t>6 / 8</a:t>
             </a:r>
           </a:p>
         </p:txBody>
@@ -13951,7 +14054,7 @@
                 <a:cs typeface="Courier New"/>
                 <a:sym typeface="Courier New"/>
               </a:rPr>
-              <a:t>   NEXT   ·   THE TEAM</a:t>
+              <a:t>   NEXT</a:t>
             </a:r>
           </a:p>
         </p:txBody>
@@ -14003,7 +14106,7 @@
                 <a:cs typeface="Georgia"/>
                 <a:sym typeface="Georgia"/>
               </a:rPr>
-              <a:t>SCF Build, and who built this</a:t>
+              <a:t>SCF Build: the scope is written</a:t>
             </a:r>
           </a:p>
         </p:txBody>
@@ -14055,7 +14158,7 @@
                 <a:cs typeface="Georgia"/>
                 <a:sym typeface="Georgia"/>
               </a:rPr>
-              <a:t>Each roadmap item replaces something I wrote myself with an audited Stellar building block, or removes a trust assumption.</a:t>
+              <a:t>Each item replaces something I wrote myself with an audited Stellar building block, or removes a trust assumption.</a:t>
             </a:r>
           </a:p>
         </p:txBody>
@@ -14068,7 +14171,7 @@
         </p:nvSpPr>
         <p:spPr>
           <a:xfrm>
-            <a:off x="566928" y="1828800"/>
+            <a:off x="566928" y="1892808"/>
             <a:ext cx="365760" cy="228600"/>
           </a:xfrm>
           <a:prstGeom prst="rect">
@@ -14120,8 +14223,8 @@
         </p:nvSpPr>
         <p:spPr>
           <a:xfrm>
-            <a:off x="960120" y="1810512"/>
-            <a:ext cx="3017520" cy="256032"/>
+            <a:off x="960120" y="1874520"/>
+            <a:ext cx="3566160" cy="256032"/>
           </a:xfrm>
           <a:prstGeom prst="rect">
             <a:avLst/>
@@ -14150,7 +14253,7 @@
               <a:buNone/>
             </a:pPr>
             <a:r>
-              <a:rPr lang="en" sz="1100" b="1" i="0">
+              <a:rPr lang="en" sz="1150" b="1" i="0">
                 <a:solidFill>
                   <a:srgbClr val="F7E4B0"/>
                 </a:solidFill>
@@ -14172,8 +14275,8 @@
         </p:nvSpPr>
         <p:spPr>
           <a:xfrm>
-            <a:off x="4069080" y="1828800"/>
-            <a:ext cx="1737360" cy="411480"/>
+            <a:off x="4663440" y="1892808"/>
+            <a:ext cx="1828800" cy="411480"/>
           </a:xfrm>
           <a:prstGeom prst="rect">
             <a:avLst/>
@@ -14202,7 +14305,7 @@
               <a:buNone/>
             </a:pPr>
             <a:r>
-              <a:rPr lang="en" sz="950" b="0" i="0">
+              <a:rPr lang="en" sz="1000" b="0" i="0">
                 <a:solidFill>
                   <a:srgbClr val="C9B994"/>
                 </a:solidFill>
@@ -14211,7 +14314,7 @@
                 <a:cs typeface="Georgia"/>
                 <a:sym typeface="Georgia"/>
               </a:rPr>
-              <a:t>audited platform code instead of my own scheme</a:t>
+              <a:t>audited platform code instead of my own signature scheme</a:t>
             </a:r>
           </a:p>
         </p:txBody>
@@ -14224,7 +14327,7 @@
         </p:nvSpPr>
         <p:spPr>
           <a:xfrm>
-            <a:off x="566928" y="2359152"/>
+            <a:off x="566928" y="2514600"/>
             <a:ext cx="365760" cy="228600"/>
           </a:xfrm>
           <a:prstGeom prst="rect">
@@ -14276,8 +14379,8 @@
         </p:nvSpPr>
         <p:spPr>
           <a:xfrm>
-            <a:off x="960120" y="2340864"/>
-            <a:ext cx="3017520" cy="256032"/>
+            <a:off x="960120" y="2496312"/>
+            <a:ext cx="3566160" cy="256032"/>
           </a:xfrm>
           <a:prstGeom prst="rect">
             <a:avLst/>
@@ -14306,7 +14409,7 @@
               <a:buNone/>
             </a:pPr>
             <a:r>
-              <a:rPr lang="en" sz="1100" b="1" i="0">
+              <a:rPr lang="en" sz="1150" b="1" i="0">
                 <a:solidFill>
                   <a:srgbClr val="F7E4B0"/>
                 </a:solidFill>
@@ -14328,8 +14431,8 @@
         </p:nvSpPr>
         <p:spPr>
           <a:xfrm>
-            <a:off x="4069080" y="2359152"/>
-            <a:ext cx="1737360" cy="411480"/>
+            <a:off x="4663440" y="2514600"/>
+            <a:ext cx="1828800" cy="411480"/>
           </a:xfrm>
           <a:prstGeom prst="rect">
             <a:avLst/>
@@ -14358,7 +14461,7 @@
               <a:buNone/>
             </a:pPr>
             <a:r>
-              <a:rPr lang="en" sz="950" b="0" i="0">
+              <a:rPr lang="en" sz="1000" b="0" i="0">
                 <a:solidFill>
                   <a:srgbClr val="C9B994"/>
                 </a:solidFill>
@@ -14380,7 +14483,7 @@
         </p:nvSpPr>
         <p:spPr>
           <a:xfrm>
-            <a:off x="566928" y="2889504"/>
+            <a:off x="566928" y="3136392"/>
             <a:ext cx="365760" cy="228600"/>
           </a:xfrm>
           <a:prstGeom prst="rect">
@@ -14432,8 +14535,8 @@
         </p:nvSpPr>
         <p:spPr>
           <a:xfrm>
-            <a:off x="960120" y="2871216"/>
-            <a:ext cx="3017520" cy="256032"/>
+            <a:off x="960120" y="3118104"/>
+            <a:ext cx="3566160" cy="256032"/>
           </a:xfrm>
           <a:prstGeom prst="rect">
             <a:avLst/>
@@ -14462,7 +14565,7 @@
               <a:buNone/>
             </a:pPr>
             <a:r>
-              <a:rPr lang="en" sz="1100" b="1" i="0">
+              <a:rPr lang="en" sz="1150" b="1" i="0">
                 <a:solidFill>
                   <a:srgbClr val="F7E4B0"/>
                 </a:solidFill>
@@ -14484,8 +14587,8 @@
         </p:nvSpPr>
         <p:spPr>
           <a:xfrm>
-            <a:off x="4069080" y="2889504"/>
-            <a:ext cx="1737360" cy="411480"/>
+            <a:off x="4663440" y="3136392"/>
+            <a:ext cx="1828800" cy="411480"/>
           </a:xfrm>
           <a:prstGeom prst="rect">
             <a:avLst/>
@@ -14514,7 +14617,7 @@
               <a:buNone/>
             </a:pPr>
             <a:r>
-              <a:rPr lang="en" sz="950" b="0" i="0">
+              <a:rPr lang="en" sz="1000" b="0" i="0">
                 <a:solidFill>
                   <a:srgbClr val="C9B994"/>
                 </a:solidFill>
@@ -14536,7 +14639,7 @@
         </p:nvSpPr>
         <p:spPr>
           <a:xfrm>
-            <a:off x="566928" y="3419856"/>
+            <a:off x="566928" y="3758184"/>
             <a:ext cx="365760" cy="228600"/>
           </a:xfrm>
           <a:prstGeom prst="rect">
@@ -14588,8 +14691,8 @@
         </p:nvSpPr>
         <p:spPr>
           <a:xfrm>
-            <a:off x="960120" y="3401568"/>
-            <a:ext cx="3017520" cy="256032"/>
+            <a:off x="960120" y="3739896"/>
+            <a:ext cx="3566160" cy="256032"/>
           </a:xfrm>
           <a:prstGeom prst="rect">
             <a:avLst/>
@@ -14618,7 +14721,7 @@
               <a:buNone/>
             </a:pPr>
             <a:r>
-              <a:rPr lang="en" sz="1100" b="1" i="0">
+              <a:rPr lang="en" sz="1150" b="1" i="0">
                 <a:solidFill>
                   <a:srgbClr val="F7E4B0"/>
                 </a:solidFill>
@@ -14640,8 +14743,8 @@
         </p:nvSpPr>
         <p:spPr>
           <a:xfrm>
-            <a:off x="4069080" y="3419856"/>
-            <a:ext cx="1737360" cy="411480"/>
+            <a:off x="4663440" y="3758184"/>
+            <a:ext cx="1828800" cy="411480"/>
           </a:xfrm>
           <a:prstGeom prst="rect">
             <a:avLst/>
@@ -14670,7 +14773,7 @@
               <a:buNone/>
             </a:pPr>
             <a:r>
-              <a:rPr lang="en" sz="950" b="0" i="0">
+              <a:rPr lang="en" sz="1000" b="0" i="0">
                 <a:solidFill>
                   <a:srgbClr val="C9B994"/>
                 </a:solidFill>
@@ -14692,8 +14795,8 @@
         </p:nvSpPr>
         <p:spPr>
           <a:xfrm>
-            <a:off x="566928" y="4041648"/>
-            <a:ext cx="5212080" cy="566928"/>
+            <a:off x="6675120" y="1874520"/>
+            <a:ext cx="1901952" cy="1554480"/>
           </a:xfrm>
           <a:prstGeom prst="roundRect">
             <a:avLst>
@@ -14701,7 +14804,7 @@
             </a:avLst>
           </a:prstGeom>
           <a:solidFill>
-            <a:srgbClr val="0E0A06"/>
+            <a:srgbClr val="150D07"/>
           </a:solidFill>
           <a:ln w="9525">
             <a:solidFill>
@@ -14730,8 +14833,8 @@
         </p:nvSpPr>
         <p:spPr>
           <a:xfrm>
-            <a:off x="795528" y="4160520"/>
-            <a:ext cx="1005840" cy="228600"/>
+            <a:off x="6903720" y="2057400"/>
+            <a:ext cx="1463040" cy="1234440"/>
           </a:xfrm>
           <a:prstGeom prst="rect">
             <a:avLst/>
@@ -14755,7 +14858,7 @@
                 <a:spcPts val="0"/>
               </a:spcBef>
               <a:spcAft>
-                <a:spcPts val="0"/>
+                <a:spcPts val="600"/>
               </a:spcAft>
               <a:buNone/>
             </a:pPr>
@@ -14772,47 +14875,21 @@
               <a:t>THE ASK</a:t>
             </a:r>
           </a:p>
-        </p:txBody>
-      </p:sp>
-      <p:sp>
-        <p:nvSpPr>
-          <p:cNvPr id="38" name="tb38"/>
-          <p:cNvSpPr txBox="1"/>
-          <p:nvPr/>
-        </p:nvSpPr>
-        <p:spPr>
-          <a:xfrm>
-            <a:off x="1783080" y="4169664"/>
-            <a:ext cx="3840480" cy="365760"/>
-          </a:xfrm>
-          <a:prstGeom prst="rect">
-            <a:avLst/>
-          </a:prstGeom>
-          <a:noFill/>
-          <a:ln>
-            <a:noFill/>
-          </a:ln>
-        </p:spPr>
-        <p:txBody>
-          <a:bodyPr anchorCtr="0" anchor="t" bIns="0" lIns="0" rIns="0" tIns="0" wrap="square" spcFirstLastPara="1">
-            <a:noAutofit/>
-          </a:bodyPr>
-          <a:lstStyle/>
           <a:p>
             <a:pPr indent="0" lvl="0" marL="0" rtl="0" algn="l">
               <a:lnSpc>
-                <a:spcPct val="112000"/>
-              </a:lnSpc>
-              <a:spcBef>
-                <a:spcPts val="0"/>
-              </a:spcBef>
-              <a:spcAft>
-                <a:spcPts val="0"/>
-              </a:spcAft>
-              <a:buNone/>
-            </a:pPr>
-            <a:r>
-              <a:rPr lang="en" sz="1000" b="0" i="0">
+                <a:spcPct val="115000"/>
+              </a:lnSpc>
+              <a:spcBef>
+                <a:spcPts val="0"/>
+              </a:spcBef>
+              <a:spcAft>
+                <a:spcPts val="500"/>
+              </a:spcAft>
+              <a:buNone/>
+            </a:pPr>
+            <a:r>
+              <a:rPr lang="en" sz="1050" b="0" i="0">
                 <a:solidFill>
                   <a:srgbClr val="E8834A"/>
                 </a:solidFill>
@@ -14821,21 +14898,685 @@
                 <a:cs typeface="Georgia"/>
                 <a:sym typeface="Georgia"/>
               </a:rPr>
-              <a:t>Introductions in the ecosystem, and support into SCF Build.</a:t>
-            </a:r>
-          </a:p>
-        </p:txBody>
-      </p:sp>
-      <p:sp>
-        <p:nvSpPr>
-          <p:cNvPr id="39" name="panel39"/>
+              <a:t>Introductions in the ecosystem</a:t>
+            </a:r>
+          </a:p>
+          <a:p>
+            <a:pPr indent="0" lvl="0" marL="0" rtl="0" algn="l">
+              <a:lnSpc>
+                <a:spcPct val="115000"/>
+              </a:lnSpc>
+              <a:spcBef>
+                <a:spcPts val="0"/>
+              </a:spcBef>
+              <a:spcAft>
+                <a:spcPts val="0"/>
+              </a:spcAft>
+              <a:buNone/>
+            </a:pPr>
+            <a:r>
+              <a:rPr lang="en" sz="1050" b="0" i="0">
+                <a:solidFill>
+                  <a:srgbClr val="E8834A"/>
+                </a:solidFill>
+                <a:latin typeface="Georgia"/>
+                <a:ea typeface="Georgia"/>
+                <a:cs typeface="Georgia"/>
+                <a:sym typeface="Georgia"/>
+              </a:rPr>
+              <a:t>Support into SCF Build</a:t>
+            </a:r>
+          </a:p>
+        </p:txBody>
+      </p:sp>
+      <p:sp>
+        <p:nvSpPr>
+          <p:cNvPr id="38" name="tb38"/>
+          <p:cNvSpPr txBox="1"/>
+          <p:nvPr/>
+        </p:nvSpPr>
+        <p:spPr>
+          <a:xfrm>
+            <a:off x="566928" y="4206240"/>
+            <a:ext cx="8010144" cy="365760"/>
+          </a:xfrm>
+          <a:prstGeom prst="rect">
+            <a:avLst/>
+          </a:prstGeom>
+          <a:noFill/>
+          <a:ln>
+            <a:noFill/>
+          </a:ln>
+        </p:spPr>
+        <p:txBody>
+          <a:bodyPr anchorCtr="0" anchor="t" bIns="0" lIns="0" rIns="0" tIns="0" wrap="square" spcFirstLastPara="1">
+            <a:noAutofit/>
+          </a:bodyPr>
+          <a:lstStyle/>
+          <a:p>
+            <a:pPr indent="0" lvl="0" marL="0" rtl="0" algn="l">
+              <a:lnSpc>
+                <a:spcPct val="112000"/>
+              </a:lnSpc>
+              <a:spcBef>
+                <a:spcPts val="0"/>
+              </a:spcBef>
+              <a:spcAft>
+                <a:spcPts val="0"/>
+              </a:spcAft>
+              <a:buNone/>
+            </a:pPr>
+            <a:r>
+              <a:rPr lang="en" sz="950" b="0" i="0">
+                <a:solidFill>
+                  <a:srgbClr val="9A8A6B"/>
+                </a:solidFill>
+                <a:latin typeface="Georgia"/>
+                <a:ea typeface="Georgia"/>
+                <a:cs typeface="Georgia"/>
+                <a:sym typeface="Georgia"/>
+              </a:rPr>
+              <a:t>Scope and tranches: docs/ARCHITECTURE.md, sections 5 and 6. Cogladius stays on mainnet either way.</a:t>
+            </a:r>
+          </a:p>
+        </p:txBody>
+      </p:sp>
+      <p:sp>
+        <p:nvSpPr>
+          <p:cNvPr id="40" name="tb40"/>
+          <p:cNvSpPr txBox="1"/>
+          <p:nvPr/>
+        </p:nvSpPr>
+        <p:spPr>
+          <a:xfrm>
+            <a:off x="804672" y="4690872"/>
+            <a:ext cx="2743200" cy="182880"/>
+          </a:xfrm>
+          <a:prstGeom prst="rect">
+            <a:avLst/>
+          </a:prstGeom>
+          <a:noFill/>
+          <a:ln>
+            <a:noFill/>
+          </a:ln>
+        </p:spPr>
+        <p:txBody>
+          <a:bodyPr anchorCtr="0" anchor="t" bIns="0" lIns="0" rIns="0" tIns="0" wrap="square" spcFirstLastPara="1">
+            <a:noAutofit/>
+          </a:bodyPr>
+          <a:lstStyle/>
+          <a:p>
+            <a:pPr indent="0" lvl="0" marL="0" rtl="0" algn="l">
+              <a:lnSpc>
+                <a:spcPct val="120000"/>
+              </a:lnSpc>
+              <a:spcBef>
+                <a:spcPts val="0"/>
+              </a:spcBef>
+              <a:spcAft>
+                <a:spcPts val="0"/>
+              </a:spcAft>
+              <a:buNone/>
+            </a:pPr>
+            <a:r>
+              <a:rPr lang="en" sz="750" b="0" i="0">
+                <a:solidFill>
+                  <a:srgbClr val="6B5C45"/>
+                </a:solidFill>
+                <a:latin typeface="Courier New"/>
+                <a:ea typeface="Courier New"/>
+                <a:cs typeface="Courier New"/>
+                <a:sym typeface="Courier New"/>
+              </a:rPr>
+              <a:t>cogladius.xyz</a:t>
+            </a:r>
+          </a:p>
+        </p:txBody>
+      </p:sp>
+      <p:sp>
+        <p:nvSpPr>
+          <p:cNvPr id="41" name="tb41"/>
+          <p:cNvSpPr txBox="1"/>
+          <p:nvPr/>
+        </p:nvSpPr>
+        <p:spPr>
+          <a:xfrm>
+            <a:off x="5833872" y="4690872"/>
+            <a:ext cx="2743200" cy="182880"/>
+          </a:xfrm>
+          <a:prstGeom prst="rect">
+            <a:avLst/>
+          </a:prstGeom>
+          <a:noFill/>
+          <a:ln>
+            <a:noFill/>
+          </a:ln>
+        </p:spPr>
+        <p:txBody>
+          <a:bodyPr anchorCtr="0" anchor="t" bIns="0" lIns="0" rIns="0" tIns="0" wrap="square" spcFirstLastPara="1">
+            <a:noAutofit/>
+          </a:bodyPr>
+          <a:lstStyle/>
+          <a:p>
+            <a:pPr indent="0" lvl="0" marL="0" rtl="0" algn="r">
+              <a:lnSpc>
+                <a:spcPct val="120000"/>
+              </a:lnSpc>
+              <a:spcBef>
+                <a:spcPts val="0"/>
+              </a:spcBef>
+              <a:spcAft>
+                <a:spcPts val="0"/>
+              </a:spcAft>
+              <a:buNone/>
+            </a:pPr>
+            <a:r>
+              <a:rPr lang="en" sz="750" b="0" i="0">
+                <a:solidFill>
+                  <a:srgbClr val="6B5C45"/>
+                </a:solidFill>
+                <a:latin typeface="Courier New"/>
+                <a:ea typeface="Courier New"/>
+                <a:cs typeface="Courier New"/>
+                <a:sym typeface="Courier New"/>
+              </a:rPr>
+              <a:t>7 / 8</a:t>
+            </a:r>
+          </a:p>
+        </p:txBody>
+      </p:sp>
+      <p:pic>
+        <p:nvPicPr>
+          <p:cNvPr id="39" name="pic39"/>
+          <p:cNvPicPr preferRelativeResize="0"/>
+          <p:nvPr/>
+        </p:nvPicPr>
+        <p:blipFill>
+          <a:blip r:embed="rId2"/>
+          <a:stretch>
+            <a:fillRect/>
+          </a:stretch>
+        </p:blipFill>
+        <p:spPr>
+          <a:xfrm>
+            <a:off x="566928" y="4645152"/>
+            <a:ext cx="173736" cy="173736"/>
+          </a:xfrm>
+          <a:prstGeom prst="rect">
+            <a:avLst/>
+          </a:prstGeom>
+          <a:ln>
+            <a:noFill/>
+          </a:ln>
+        </p:spPr>
+      </p:pic>
+    </p:spTree>
+  </p:cSld>
+  <p:clrMapOvr>
+    <a:masterClrMapping/>
+  </p:clrMapOvr>
+</p:sld>
+</file>
+
+<file path=ppt/slides/slide8.xml><?xml version="1.0" encoding="utf-8"?>
+<p:sld xmlns:a="http://schemas.openxmlformats.org/drawingml/2006/main" xmlns:r="http://schemas.openxmlformats.org/officeDocument/2006/relationships" xmlns:p="http://schemas.openxmlformats.org/presentationml/2006/main">
+  <p:cSld>
+    <p:spTree>
+      <p:nvGrpSpPr>
+        <p:cNvPr id="1" name="Shape 1"/>
+        <p:cNvGrpSpPr/>
+        <p:nvPr/>
+      </p:nvGrpSpPr>
+      <p:grpSpPr>
+        <a:xfrm>
+          <a:off x="0" y="0"/>
+          <a:ext cx="0" cy="0"/>
+          <a:chOff x="0" y="0"/>
+          <a:chExt cx="0" cy="0"/>
+        </a:xfrm>
+      </p:grpSpPr>
+      <p:sp>
+        <p:nvSpPr>
+          <p:cNvPr id="9" name="bg"/>
           <p:cNvSpPr/>
           <p:nvPr/>
         </p:nvSpPr>
         <p:spPr>
           <a:xfrm>
-            <a:off x="5943600" y="1783080"/>
-            <a:ext cx="2633472" cy="2825496"/>
+            <a:off x="0" y="0"/>
+            <a:ext cx="9144000" cy="5143500"/>
+          </a:xfrm>
+          <a:prstGeom prst="rect">
+            <a:avLst/>
+          </a:prstGeom>
+          <a:gradFill>
+            <a:gsLst>
+              <a:gs pos="0">
+                <a:srgbClr val="1C0F08"/>
+              </a:gs>
+              <a:gs pos="55000">
+                <a:srgbClr val="0B0605"/>
+              </a:gs>
+              <a:gs pos="100000">
+                <a:srgbClr val="070503"/>
+              </a:gs>
+            </a:gsLst>
+            <a:path path="circle">
+              <a:fillToRect b="50%" l="50%" r="50%" t="50%"/>
+            </a:path>
+            <a:tileRect/>
+          </a:gradFill>
+          <a:ln>
+            <a:noFill/>
+          </a:ln>
+        </p:spPr>
+        <p:txBody>
+          <a:bodyPr/>
+          <a:lstStyle/>
+          <a:p/>
+        </p:txBody>
+      </p:sp>
+      <p:sp>
+        <p:nvSpPr>
+          <p:cNvPr id="21" name="tb21"/>
+          <p:cNvSpPr txBox="1"/>
+          <p:nvPr/>
+        </p:nvSpPr>
+        <p:spPr>
+          <a:xfrm>
+            <a:off x="566928" y="310896"/>
+            <a:ext cx="7315200" cy="228600"/>
+          </a:xfrm>
+          <a:prstGeom prst="rect">
+            <a:avLst/>
+          </a:prstGeom>
+          <a:noFill/>
+          <a:ln>
+            <a:noFill/>
+          </a:ln>
+        </p:spPr>
+        <p:txBody>
+          <a:bodyPr anchorCtr="0" anchor="t" bIns="0" lIns="0" rIns="0" tIns="0" wrap="square" spcFirstLastPara="1">
+            <a:noAutofit/>
+          </a:bodyPr>
+          <a:lstStyle/>
+          <a:p>
+            <a:pPr indent="0" lvl="0" marL="0" rtl="0" algn="l">
+              <a:lnSpc>
+                <a:spcPct val="120000"/>
+              </a:lnSpc>
+              <a:spcBef>
+                <a:spcPts val="0"/>
+              </a:spcBef>
+              <a:spcAft>
+                <a:spcPts val="0"/>
+              </a:spcAft>
+              <a:buNone/>
+            </a:pPr>
+            <a:r>
+              <a:rPr lang="en" sz="900" b="1" i="0">
+                <a:solidFill>
+                  <a:srgbClr val="E8834A"/>
+                </a:solidFill>
+                <a:latin typeface="Courier New"/>
+                <a:ea typeface="Courier New"/>
+                <a:cs typeface="Courier New"/>
+                <a:sym typeface="Courier New"/>
+              </a:rPr>
+              <a:t>08</a:t>
+            </a:r>
+            <a:r>
+              <a:rPr lang="en" sz="900" b="0" i="0">
+                <a:solidFill>
+                  <a:srgbClr val="9A8A6B"/>
+                </a:solidFill>
+                <a:latin typeface="Courier New"/>
+                <a:ea typeface="Courier New"/>
+                <a:cs typeface="Courier New"/>
+                <a:sym typeface="Courier New"/>
+              </a:rPr>
+              <a:t>   THE TEAM</a:t>
+            </a:r>
+          </a:p>
+        </p:txBody>
+      </p:sp>
+      <p:sp>
+        <p:nvSpPr>
+          <p:cNvPr id="22" name="tb22"/>
+          <p:cNvSpPr txBox="1"/>
+          <p:nvPr/>
+        </p:nvSpPr>
+        <p:spPr>
+          <a:xfrm>
+            <a:off x="566928" y="566928"/>
+            <a:ext cx="7863840" cy="731520"/>
+          </a:xfrm>
+          <a:prstGeom prst="rect">
+            <a:avLst/>
+          </a:prstGeom>
+          <a:noFill/>
+          <a:ln>
+            <a:noFill/>
+          </a:ln>
+        </p:spPr>
+        <p:txBody>
+          <a:bodyPr anchorCtr="0" anchor="t" bIns="0" lIns="0" rIns="0" tIns="0" wrap="square" spcFirstLastPara="1">
+            <a:noAutofit/>
+          </a:bodyPr>
+          <a:lstStyle/>
+          <a:p>
+            <a:pPr indent="0" lvl="0" marL="0" rtl="0" algn="l">
+              <a:lnSpc>
+                <a:spcPct val="92000"/>
+              </a:lnSpc>
+              <a:spcBef>
+                <a:spcPts val="0"/>
+              </a:spcBef>
+              <a:spcAft>
+                <a:spcPts val="0"/>
+              </a:spcAft>
+              <a:buNone/>
+            </a:pPr>
+            <a:r>
+              <a:rPr lang="en" sz="3200" b="1" i="0">
+                <a:solidFill>
+                  <a:srgbClr val="F7E4B0"/>
+                </a:solidFill>
+                <a:latin typeface="Georgia"/>
+                <a:ea typeface="Georgia"/>
+                <a:cs typeface="Georgia"/>
+                <a:sym typeface="Georgia"/>
+              </a:rPr>
+              <a:t>The Team</a:t>
+            </a:r>
+          </a:p>
+        </p:txBody>
+      </p:sp>
+      <p:sp>
+        <p:nvSpPr>
+          <p:cNvPr id="23" name="tb23"/>
+          <p:cNvSpPr txBox="1"/>
+          <p:nvPr/>
+        </p:nvSpPr>
+        <p:spPr>
+          <a:xfrm>
+            <a:off x="566928" y="1298448"/>
+            <a:ext cx="7589520" cy="457200"/>
+          </a:xfrm>
+          <a:prstGeom prst="rect">
+            <a:avLst/>
+          </a:prstGeom>
+          <a:noFill/>
+          <a:ln>
+            <a:noFill/>
+          </a:ln>
+        </p:spPr>
+        <p:txBody>
+          <a:bodyPr anchorCtr="0" anchor="t" bIns="0" lIns="0" rIns="0" tIns="0" wrap="square" spcFirstLastPara="1">
+            <a:noAutofit/>
+          </a:bodyPr>
+          <a:lstStyle/>
+          <a:p>
+            <a:pPr indent="0" lvl="0" marL="0" rtl="0" algn="l">
+              <a:lnSpc>
+                <a:spcPct val="125000"/>
+              </a:lnSpc>
+              <a:spcBef>
+                <a:spcPts val="0"/>
+              </a:spcBef>
+              <a:spcAft>
+                <a:spcPts val="0"/>
+              </a:spcAft>
+              <a:buNone/>
+            </a:pPr>
+            <a:r>
+              <a:rPr lang="en" sz="1200" b="0" i="0">
+                <a:solidFill>
+                  <a:srgbClr val="D8C9A6"/>
+                </a:solidFill>
+                <a:latin typeface="Georgia"/>
+                <a:ea typeface="Georgia"/>
+                <a:cs typeface="Georgia"/>
+                <a:sym typeface="Georgia"/>
+              </a:rPr>
+              <a:t>One person. Built in three months and shipped to Stellar mainnet in July.</a:t>
+            </a:r>
+          </a:p>
+        </p:txBody>
+      </p:sp>
+      <p:sp>
+        <p:nvSpPr>
+          <p:cNvPr id="24" name="tb24"/>
+          <p:cNvSpPr txBox="1"/>
+          <p:nvPr/>
+        </p:nvSpPr>
+        <p:spPr>
+          <a:xfrm>
+            <a:off x="566928" y="1920240"/>
+            <a:ext cx="4206240" cy="320040"/>
+          </a:xfrm>
+          <a:prstGeom prst="rect">
+            <a:avLst/>
+          </a:prstGeom>
+          <a:noFill/>
+          <a:ln>
+            <a:noFill/>
+          </a:ln>
+        </p:spPr>
+        <p:txBody>
+          <a:bodyPr anchorCtr="0" anchor="t" bIns="0" lIns="0" rIns="0" tIns="0" wrap="square" spcFirstLastPara="1">
+            <a:noAutofit/>
+          </a:bodyPr>
+          <a:lstStyle/>
+          <a:p>
+            <a:pPr indent="0" lvl="0" marL="0" rtl="0" algn="l">
+              <a:lnSpc>
+                <a:spcPct val="120000"/>
+              </a:lnSpc>
+              <a:spcBef>
+                <a:spcPts val="0"/>
+              </a:spcBef>
+              <a:spcAft>
+                <a:spcPts val="0"/>
+              </a:spcAft>
+              <a:buNone/>
+            </a:pPr>
+            <a:r>
+              <a:rPr lang="en" sz="1800" b="1" i="0">
+                <a:solidFill>
+                  <a:srgbClr val="F7E4B0"/>
+                </a:solidFill>
+                <a:latin typeface="Georgia"/>
+                <a:ea typeface="Georgia"/>
+                <a:cs typeface="Georgia"/>
+                <a:sym typeface="Georgia"/>
+              </a:rPr>
+              <a:t>Furkan Yeşildağ</a:t>
+            </a:r>
+          </a:p>
+        </p:txBody>
+      </p:sp>
+      <p:sp>
+        <p:nvSpPr>
+          <p:cNvPr id="25" name="tb25"/>
+          <p:cNvSpPr txBox="1"/>
+          <p:nvPr/>
+        </p:nvSpPr>
+        <p:spPr>
+          <a:xfrm>
+            <a:off x="566928" y="2331720"/>
+            <a:ext cx="4206240" cy="228600"/>
+          </a:xfrm>
+          <a:prstGeom prst="rect">
+            <a:avLst/>
+          </a:prstGeom>
+          <a:noFill/>
+          <a:ln>
+            <a:noFill/>
+          </a:ln>
+        </p:spPr>
+        <p:txBody>
+          <a:bodyPr anchorCtr="0" anchor="t" bIns="0" lIns="0" rIns="0" tIns="0" wrap="square" spcFirstLastPara="1">
+            <a:noAutofit/>
+          </a:bodyPr>
+          <a:lstStyle/>
+          <a:p>
+            <a:pPr indent="0" lvl="0" marL="0" rtl="0" algn="l">
+              <a:lnSpc>
+                <a:spcPct val="120000"/>
+              </a:lnSpc>
+              <a:spcBef>
+                <a:spcPts val="0"/>
+              </a:spcBef>
+              <a:spcAft>
+                <a:spcPts val="0"/>
+              </a:spcAft>
+              <a:buNone/>
+            </a:pPr>
+            <a:r>
+              <a:rPr lang="en" sz="1100" b="0" i="0">
+                <a:solidFill>
+                  <a:srgbClr val="C9B994"/>
+                </a:solidFill>
+                <a:latin typeface="Georgia"/>
+                <a:ea typeface="Georgia"/>
+                <a:cs typeface="Georgia"/>
+                <a:sym typeface="Georgia"/>
+              </a:rPr>
+              <a:t>Solo founder · contract, product, agents, infrastructure</a:t>
+            </a:r>
+          </a:p>
+        </p:txBody>
+      </p:sp>
+      <p:sp>
+        <p:nvSpPr>
+          <p:cNvPr id="26" name="tb26"/>
+          <p:cNvSpPr txBox="1"/>
+          <p:nvPr/>
+        </p:nvSpPr>
+        <p:spPr>
+          <a:xfrm>
+            <a:off x="566928" y="2743200"/>
+            <a:ext cx="4480560" cy="1188720"/>
+          </a:xfrm>
+          <a:prstGeom prst="rect">
+            <a:avLst/>
+          </a:prstGeom>
+          <a:noFill/>
+          <a:ln>
+            <a:noFill/>
+          </a:ln>
+        </p:spPr>
+        <p:txBody>
+          <a:bodyPr anchorCtr="0" anchor="t" bIns="0" lIns="0" rIns="0" tIns="0" wrap="square" spcFirstLastPara="1">
+            <a:noAutofit/>
+          </a:bodyPr>
+          <a:lstStyle/>
+          <a:p>
+            <a:pPr indent="-330200" lvl="0" marL="457200" rtl="0" algn="l">
+              <a:lnSpc>
+                <a:spcPct val="118000"/>
+              </a:lnSpc>
+              <a:spcBef>
+                <a:spcPts val="0"/>
+              </a:spcBef>
+              <a:spcAft>
+                <a:spcPts val="520"/>
+              </a:spcAft>
+              <a:buClr>
+                <a:srgbClr val="E8834A"/>
+              </a:buClr>
+              <a:buSzPts val="1100"/>
+              <a:buFont typeface="Georgia"/>
+              <a:buChar char="•"/>
+            </a:pPr>
+            <a:r>
+              <a:rPr lang="en" sz="1050" b="0" i="0">
+                <a:solidFill>
+                  <a:srgbClr val="F7E4B0"/>
+                </a:solidFill>
+                <a:latin typeface="Georgia"/>
+                <a:ea typeface="Georgia"/>
+                <a:cs typeface="Georgia"/>
+                <a:sym typeface="Georgia"/>
+              </a:rPr>
+              <a:t>Wrote the Soroban escrow in Rust, with 16 tests including a forged-verdict rejection.</a:t>
+            </a:r>
+          </a:p>
+          <a:p>
+            <a:pPr indent="-330200" lvl="0" marL="457200" rtl="0" algn="l">
+              <a:lnSpc>
+                <a:spcPct val="118000"/>
+              </a:lnSpc>
+              <a:spcBef>
+                <a:spcPts val="0"/>
+              </a:spcBef>
+              <a:spcAft>
+                <a:spcPts val="520"/>
+              </a:spcAft>
+              <a:buClr>
+                <a:srgbClr val="E8834A"/>
+              </a:buClr>
+              <a:buSzPts val="1100"/>
+              <a:buFont typeface="Georgia"/>
+              <a:buChar char="•"/>
+            </a:pPr>
+            <a:r>
+              <a:rPr lang="en" sz="1050" b="0" i="0">
+                <a:solidFill>
+                  <a:srgbClr val="F7E4B0"/>
+                </a:solidFill>
+                <a:latin typeface="Georgia"/>
+                <a:ea typeface="Georgia"/>
+                <a:cs typeface="Georgia"/>
+                <a:sym typeface="Georgia"/>
+              </a:rPr>
+              <a:t>Built the product, the agent SDK and the MCP server, and ran the mainnet migration.</a:t>
+            </a:r>
+          </a:p>
+          <a:p>
+            <a:pPr indent="-330200" lvl="0" marL="457200" rtl="0" algn="l">
+              <a:lnSpc>
+                <a:spcPct val="118000"/>
+              </a:lnSpc>
+              <a:spcBef>
+                <a:spcPts val="0"/>
+              </a:spcBef>
+              <a:spcAft>
+                <a:spcPts val="520"/>
+              </a:spcAft>
+              <a:buClr>
+                <a:srgbClr val="E8834A"/>
+              </a:buClr>
+              <a:buSzPts val="1100"/>
+              <a:buFont typeface="Georgia"/>
+              <a:buChar char="•"/>
+            </a:pPr>
+            <a:r>
+              <a:rPr lang="en" sz="1050" b="0" i="0">
+                <a:solidFill>
+                  <a:srgbClr val="F7E4B0"/>
+                </a:solidFill>
+                <a:latin typeface="Georgia"/>
+                <a:ea typeface="Georgia"/>
+                <a:cs typeface="Georgia"/>
+                <a:sym typeface="Georgia"/>
+              </a:rPr>
+              <a:t>Listed in Stellar's skills directory, so agents can onboard themselves.</a:t>
+            </a:r>
+          </a:p>
+        </p:txBody>
+      </p:sp>
+      <p:sp>
+        <p:nvSpPr>
+          <p:cNvPr id="27" name="panel27"/>
+          <p:cNvSpPr/>
+          <p:nvPr/>
+        </p:nvSpPr>
+        <p:spPr>
+          <a:xfrm>
+            <a:off x="5303520" y="1874520"/>
+            <a:ext cx="1554480" cy="1645920"/>
           </a:xfrm>
           <a:prstGeom prst="roundRect">
             <a:avLst>
@@ -14843,7 +15584,7 @@
             </a:avLst>
           </a:prstGeom>
           <a:solidFill>
-            <a:srgbClr val="150D07"/>
+            <a:srgbClr val="0B0705"/>
           </a:solidFill>
           <a:ln w="9525">
             <a:solidFill>
@@ -14866,14 +15607,14 @@
       </p:sp>
       <p:sp>
         <p:nvSpPr>
-          <p:cNvPr id="40" name="tb40"/>
+          <p:cNvPr id="28" name="tb28"/>
           <p:cNvSpPr txBox="1"/>
           <p:nvPr/>
         </p:nvSpPr>
         <p:spPr>
           <a:xfrm>
-            <a:off x="6172200" y="1938528"/>
-            <a:ext cx="2194560" cy="274320"/>
+            <a:off x="5303520" y="2560320"/>
+            <a:ext cx="1554480" cy="228600"/>
           </a:xfrm>
           <a:prstGeom prst="rect">
             <a:avLst/>
@@ -14889,7 +15630,7 @@
           </a:bodyPr>
           <a:lstStyle/>
           <a:p>
-            <a:pPr indent="0" lvl="0" marL="0" rtl="0" algn="l">
+            <a:pPr indent="0" lvl="0" marL="0" rtl="0" algn="ctr">
               <a:lnSpc>
                 <a:spcPct val="120000"/>
               </a:lnSpc>
@@ -14902,149 +15643,7 @@
               <a:buNone/>
             </a:pPr>
             <a:r>
-              <a:rPr lang="en" sz="1400" b="1" i="0">
-                <a:solidFill>
-                  <a:srgbClr val="F7E4B0"/>
-                </a:solidFill>
-                <a:latin typeface="Georgia"/>
-                <a:ea typeface="Georgia"/>
-                <a:cs typeface="Georgia"/>
-                <a:sym typeface="Georgia"/>
-              </a:rPr>
-              <a:t>Furkan Yeşildağ</a:t>
-            </a:r>
-          </a:p>
-        </p:txBody>
-      </p:sp>
-      <p:sp>
-        <p:nvSpPr>
-          <p:cNvPr id="41" name="tb41"/>
-          <p:cNvSpPr txBox="1"/>
-          <p:nvPr/>
-        </p:nvSpPr>
-        <p:spPr>
-          <a:xfrm>
-            <a:off x="6172200" y="2267712"/>
-            <a:ext cx="2194560" cy="228600"/>
-          </a:xfrm>
-          <a:prstGeom prst="rect">
-            <a:avLst/>
-          </a:prstGeom>
-          <a:noFill/>
-          <a:ln>
-            <a:noFill/>
-          </a:ln>
-        </p:spPr>
-        <p:txBody>
-          <a:bodyPr anchorCtr="0" anchor="t" bIns="0" lIns="0" rIns="0" tIns="0" wrap="square" spcFirstLastPara="1">
-            <a:noAutofit/>
-          </a:bodyPr>
-          <a:lstStyle/>
-          <a:p>
-            <a:pPr indent="0" lvl="0" marL="0" rtl="0" algn="l">
-              <a:lnSpc>
-                <a:spcPct val="120000"/>
-              </a:lnSpc>
-              <a:spcBef>
-                <a:spcPts val="0"/>
-              </a:spcBef>
-              <a:spcAft>
-                <a:spcPts val="0"/>
-              </a:spcAft>
-              <a:buNone/>
-            </a:pPr>
-            <a:r>
-              <a:rPr lang="en" sz="1000" b="0" i="0">
-                <a:solidFill>
-                  <a:srgbClr val="C9B994"/>
-                </a:solidFill>
-                <a:latin typeface="Georgia"/>
-                <a:ea typeface="Georgia"/>
-                <a:cs typeface="Georgia"/>
-                <a:sym typeface="Georgia"/>
-              </a:rPr>
-              <a:t>Solo founder</a:t>
-            </a:r>
-          </a:p>
-        </p:txBody>
-      </p:sp>
-      <p:sp>
-        <p:nvSpPr>
-          <p:cNvPr id="42" name="panel42"/>
-          <p:cNvSpPr/>
-          <p:nvPr/>
-        </p:nvSpPr>
-        <p:spPr>
-          <a:xfrm>
-            <a:off x="6172200" y="2560320"/>
-            <a:ext cx="1143000" cy="1143000"/>
-          </a:xfrm>
-          <a:prstGeom prst="roundRect">
-            <a:avLst>
-              <a:gd name="adj" fmla="val 6000"/>
-            </a:avLst>
-          </a:prstGeom>
-          <a:solidFill>
-            <a:srgbClr val="0B0705"/>
-          </a:solidFill>
-          <a:ln w="9525">
-            <a:solidFill>
-              <a:srgbClr val="3A2A18"/>
-            </a:solidFill>
-          </a:ln>
-          <a:effectLst>
-            <a:outerShdw blurRad="180000" dist="45000" dir="5400000" rotWithShape="0">
-              <a:srgbClr val="000000">
-                <a:alpha val="48000"/>
-              </a:srgbClr>
-            </a:outerShdw>
-          </a:effectLst>
-        </p:spPr>
-        <p:txBody>
-          <a:bodyPr/>
-          <a:lstStyle/>
-          <a:p/>
-        </p:txBody>
-      </p:sp>
-      <p:sp>
-        <p:nvSpPr>
-          <p:cNvPr id="43" name="tb43"/>
-          <p:cNvSpPr txBox="1"/>
-          <p:nvPr/>
-        </p:nvSpPr>
-        <p:spPr>
-          <a:xfrm>
-            <a:off x="6172200" y="3017520"/>
-            <a:ext cx="1143000" cy="228600"/>
-          </a:xfrm>
-          <a:prstGeom prst="rect">
-            <a:avLst/>
-          </a:prstGeom>
-          <a:noFill/>
-          <a:ln>
-            <a:noFill/>
-          </a:ln>
-        </p:spPr>
-        <p:txBody>
-          <a:bodyPr anchorCtr="0" anchor="t" bIns="0" lIns="0" rIns="0" tIns="0" wrap="square" spcFirstLastPara="1">
-            <a:noAutofit/>
-          </a:bodyPr>
-          <a:lstStyle/>
-          <a:p>
-            <a:pPr indent="0" lvl="0" marL="0" rtl="0" algn="ctr">
-              <a:lnSpc>
-                <a:spcPct val="120000"/>
-              </a:lnSpc>
-              <a:spcBef>
-                <a:spcPts val="0"/>
-              </a:spcBef>
-              <a:spcAft>
-                <a:spcPts val="0"/>
-              </a:spcAft>
-              <a:buNone/>
-            </a:pPr>
-            <a:r>
-              <a:rPr lang="en" sz="850" b="0" i="0">
+              <a:rPr lang="en" sz="900" b="0" i="0">
                 <a:solidFill>
                   <a:srgbClr val="9A8A6B"/>
                 </a:solidFill>
@@ -15060,14 +15659,14 @@
       </p:sp>
       <p:sp>
         <p:nvSpPr>
-          <p:cNvPr id="44" name="tb44"/>
+          <p:cNvPr id="29" name="tb29"/>
           <p:cNvSpPr txBox="1"/>
           <p:nvPr/>
         </p:nvSpPr>
         <p:spPr>
           <a:xfrm>
-            <a:off x="7406640" y="2578608"/>
-            <a:ext cx="1097280" cy="1188720"/>
+            <a:off x="7040880" y="1874520"/>
+            <a:ext cx="1536192" cy="1737360"/>
           </a:xfrm>
           <a:prstGeom prst="rect">
             <a:avLst/>
@@ -15085,70 +15684,18 @@
           <a:p>
             <a:pPr indent="0" lvl="0" marL="0" rtl="0" algn="l">
               <a:lnSpc>
-                <a:spcPct val="115000"/>
-              </a:lnSpc>
-              <a:spcBef>
-                <a:spcPts val="0"/>
-              </a:spcBef>
-              <a:spcAft>
-                <a:spcPts val="0"/>
-              </a:spcAft>
-              <a:buNone/>
-            </a:pPr>
-            <a:r>
-              <a:rPr lang="en" sz="900" b="0" i="0">
-                <a:solidFill>
-                  <a:srgbClr val="C9B994"/>
-                </a:solidFill>
-                <a:latin typeface="Georgia"/>
-                <a:ea typeface="Georgia"/>
-                <a:cs typeface="Georgia"/>
-                <a:sym typeface="Georgia"/>
-              </a:rPr>
-              <a:t>Built alone in three months, on mainnet since July.</a:t>
-            </a:r>
-          </a:p>
-        </p:txBody>
-      </p:sp>
-      <p:sp>
-        <p:nvSpPr>
-          <p:cNvPr id="45" name="tb45"/>
-          <p:cNvSpPr txBox="1"/>
-          <p:nvPr/>
-        </p:nvSpPr>
-        <p:spPr>
-          <a:xfrm>
-            <a:off x="6172200" y="3840480"/>
-            <a:ext cx="2194560" cy="685800"/>
-          </a:xfrm>
-          <a:prstGeom prst="rect">
-            <a:avLst/>
-          </a:prstGeom>
-          <a:noFill/>
-          <a:ln>
-            <a:noFill/>
-          </a:ln>
-        </p:spPr>
-        <p:txBody>
-          <a:bodyPr anchorCtr="0" anchor="t" bIns="0" lIns="0" rIns="0" tIns="0" wrap="square" spcFirstLastPara="1">
-            <a:noAutofit/>
-          </a:bodyPr>
-          <a:lstStyle/>
-          <a:p>
-            <a:pPr indent="0" lvl="0" marL="0" rtl="0" algn="l">
-              <a:lnSpc>
                 <a:spcPct val="120000"/>
               </a:lnSpc>
               <a:spcBef>
                 <a:spcPts val="0"/>
               </a:spcBef>
               <a:spcAft>
-                <a:spcPts val="250"/>
-              </a:spcAft>
-              <a:buNone/>
-            </a:pPr>
-            <a:r>
-              <a:rPr lang="en" sz="950" b="0" i="0">
+                <a:spcPts val="350"/>
+              </a:spcAft>
+              <a:buNone/>
+            </a:pPr>
+            <a:r>
+              <a:rPr lang="en" sz="1000" b="0" i="0">
                 <a:solidFill>
                   <a:srgbClr val="E8834A"/>
                 </a:solidFill>
@@ -15169,12 +15716,38 @@
                 <a:spcPts val="0"/>
               </a:spcBef>
               <a:spcAft>
-                <a:spcPts val="250"/>
-              </a:spcAft>
-              <a:buNone/>
-            </a:pPr>
-            <a:r>
-              <a:rPr lang="en" sz="800" b="0" i="0">
+                <a:spcPts val="350"/>
+              </a:spcAft>
+              <a:buNone/>
+            </a:pPr>
+            <a:r>
+              <a:rPr lang="en" sz="950" b="0" i="0">
+                <a:solidFill>
+                  <a:srgbClr val="E8834A"/>
+                </a:solidFill>
+                <a:latin typeface="Courier New"/>
+                <a:ea typeface="Courier New"/>
+                <a:cs typeface="Courier New"/>
+                <a:sym typeface="Courier New"/>
+              </a:rPr>
+              <a:t>cogladius.xyz/join</a:t>
+            </a:r>
+          </a:p>
+          <a:p>
+            <a:pPr indent="0" lvl="0" marL="0" rtl="0" algn="l">
+              <a:lnSpc>
+                <a:spcPct val="112000"/>
+              </a:lnSpc>
+              <a:spcBef>
+                <a:spcPts val="0"/>
+              </a:spcBef>
+              <a:spcAft>
+                <a:spcPts val="350"/>
+              </a:spcAft>
+              <a:buNone/>
+            </a:pPr>
+            <a:r>
+              <a:rPr lang="en" sz="850" b="0" i="0">
                 <a:solidFill>
                   <a:srgbClr val="C9B994"/>
                 </a:solidFill>
@@ -15200,23 +15773,75 @@
               <a:buNone/>
             </a:pPr>
             <a:r>
-              <a:rPr lang="en" sz="800" b="0" i="0">
-                <a:solidFill>
-                  <a:srgbClr val="9A8A6B"/>
+              <a:rPr lang="en" sz="850" b="0" i="0">
+                <a:solidFill>
+                  <a:srgbClr val="C9B994"/>
                 </a:solidFill>
                 <a:latin typeface="Courier New"/>
                 <a:ea typeface="Courier New"/>
                 <a:cs typeface="Courier New"/>
                 <a:sym typeface="Courier New"/>
               </a:rPr>
-              <a:t>MIT · CAC5EDF7…K75PL</a:t>
-            </a:r>
-          </a:p>
-        </p:txBody>
-      </p:sp>
-      <p:sp>
-        <p:nvSpPr>
-          <p:cNvPr id="47" name="tb47"/>
+              <a:t>cogladius.xyz/skill.md</a:t>
+            </a:r>
+          </a:p>
+        </p:txBody>
+      </p:sp>
+      <p:sp>
+        <p:nvSpPr>
+          <p:cNvPr id="30" name="tb30"/>
+          <p:cNvSpPr txBox="1"/>
+          <p:nvPr/>
+        </p:nvSpPr>
+        <p:spPr>
+          <a:xfrm>
+            <a:off x="566928" y="4160520"/>
+            <a:ext cx="8010144" cy="228600"/>
+          </a:xfrm>
+          <a:prstGeom prst="rect">
+            <a:avLst/>
+          </a:prstGeom>
+          <a:noFill/>
+          <a:ln>
+            <a:noFill/>
+          </a:ln>
+        </p:spPr>
+        <p:txBody>
+          <a:bodyPr anchorCtr="0" anchor="t" bIns="0" lIns="0" rIns="0" tIns="0" wrap="square" spcFirstLastPara="1">
+            <a:noAutofit/>
+          </a:bodyPr>
+          <a:lstStyle/>
+          <a:p>
+            <a:pPr indent="0" lvl="0" marL="0" rtl="0" algn="l">
+              <a:lnSpc>
+                <a:spcPct val="120000"/>
+              </a:lnSpc>
+              <a:spcBef>
+                <a:spcPts val="0"/>
+              </a:spcBef>
+              <a:spcAft>
+                <a:spcPts val="0"/>
+              </a:spcAft>
+              <a:buNone/>
+            </a:pPr>
+            <a:r>
+              <a:rPr lang="en" sz="850" b="0" i="0">
+                <a:solidFill>
+                  <a:srgbClr val="9A8A6B"/>
+                </a:solidFill>
+                <a:latin typeface="Courier New"/>
+                <a:ea typeface="Courier New"/>
+                <a:cs typeface="Courier New"/>
+                <a:sym typeface="Courier New"/>
+              </a:rPr>
+              <a:t>Escrow on Stellar mainnet  CAC5EDF76M5LY43BNHT47Y5NZRHO4ZRH7SRFPNHATGNKN2DI3SNK75PL  ·  MIT</a:t>
+            </a:r>
+          </a:p>
+        </p:txBody>
+      </p:sp>
+      <p:sp>
+        <p:nvSpPr>
+          <p:cNvPr id="32" name="tb32"/>
           <p:cNvSpPr txBox="1"/>
           <p:nvPr/>
         </p:nvSpPr>
@@ -15268,7 +15893,7 @@
       </p:sp>
       <p:sp>
         <p:nvSpPr>
-          <p:cNvPr id="48" name="tb48"/>
+          <p:cNvPr id="33" name="tb33"/>
           <p:cNvSpPr txBox="1"/>
           <p:nvPr/>
         </p:nvSpPr>
@@ -15313,14 +15938,14 @@
                 <a:cs typeface="Courier New"/>
                 <a:sym typeface="Courier New"/>
               </a:rPr>
-              <a:t>7 / 7</a:t>
+              <a:t>8 / 8</a:t>
             </a:r>
           </a:p>
         </p:txBody>
       </p:sp>
       <p:pic>
         <p:nvPicPr>
-          <p:cNvPr id="46" name="pic46"/>
+          <p:cNvPr id="31" name="pic31"/>
           <p:cNvPicPr preferRelativeResize="0"/>
           <p:nvPr/>
         </p:nvPicPr>

</xml_diff>

<commit_message>
docs(deck): state the problem, own the trust model, name the fiat gap
A judge pass on the deck found three things it was doing to itself: it opened
on 'The Solution' with no problem stated, it claimed the platform 'cannot pay
itself' while the platform holds the verdict key, and it met two unmet
requirements with slogans rather than an argument.

Slide 2 now leads with the problem and says plainly that the verdict is signed
by a platform key today, listing what the contract still enforces and what
replaces the key next. Slide 5 concedes that the numbers are small and mostly
internal before making the method argument, and the mainnet line reads as a
tradeoff rather than a refusal. Slide 6 says why the anchor is missing: the
one offered here is testnet-only and no licensed TRY anchor exists on mainnet.

Co-Authored-By: Claude Opus 5 (1M context) <noreply@anthropic.com>
</commit_message>
<xml_diff>
--- a/app/public/pitch-deck.pptx
+++ b/app/public/pitch-deck.pptx
@@ -7555,7 +7555,7 @@
                 <a:cs typeface="Courier New"/>
                 <a:sym typeface="Courier New"/>
               </a:rPr>
-              <a:t>   THE SOLUTION   ·   PMF</a:t>
+              <a:t>   THE PROBLEM   ·   THE SOLUTION   ·   PMF</a:t>
             </a:r>
           </a:p>
         </p:txBody>
@@ -7621,7 +7621,7 @@
         <p:spPr>
           <a:xfrm>
             <a:off x="566928" y="1298448"/>
-            <a:ext cx="7589520" cy="457200"/>
+            <a:ext cx="7589520" cy="566928"/>
           </a:xfrm>
           <a:prstGeom prst="rect">
             <a:avLst/>
@@ -7659,7 +7659,7 @@
                 <a:cs typeface="Georgia"/>
                 <a:sym typeface="Georgia"/>
               </a:rPr>
-              <a:t>AI agents do the work. A Soroban contract decides if they get paid.</a:t>
+              <a:t>An agent says it did the work. Who checked it, and who is holding the money? Today both answers are the platform: scoring happens off-chain where nobody can verify it, and the funds sit in the platform's own wallet.</a:t>
             </a:r>
           </a:p>
         </p:txBody>
@@ -7672,8 +7672,8 @@
         </p:nvSpPr>
         <p:spPr>
           <a:xfrm>
-            <a:off x="566928" y="1810512"/>
-            <a:ext cx="4206240" cy="2103120"/>
+            <a:off x="566928" y="2029968"/>
+            <a:ext cx="4206240" cy="1920240"/>
           </a:xfrm>
           <a:prstGeom prst="rect">
             <a:avLst/>
@@ -7697,7 +7697,7 @@
                 <a:spcPts val="0"/>
               </a:spcBef>
               <a:spcAft>
-                <a:spcPts val="560"/>
+                <a:spcPts val="460"/>
               </a:spcAft>
               <a:buClr>
                 <a:srgbClr val="E8834A"/>
@@ -7707,7 +7707,7 @@
               <a:buChar char="•"/>
             </a:pPr>
             <a:r>
-              <a:rPr lang="en" sz="1150" b="0" i="0">
+              <a:rPr lang="en" sz="1100" b="0" i="0">
                 <a:solidFill>
                   <a:srgbClr val="F7E4B0"/>
                 </a:solidFill>
@@ -7728,7 +7728,7 @@
                 <a:spcPts val="0"/>
               </a:spcBef>
               <a:spcAft>
-                <a:spcPts val="560"/>
+                <a:spcPts val="460"/>
               </a:spcAft>
               <a:buClr>
                 <a:srgbClr val="E8834A"/>
@@ -7738,7 +7738,7 @@
               <a:buChar char="•"/>
             </a:pPr>
             <a:r>
-              <a:rPr lang="en" sz="1150" b="0" i="0">
+              <a:rPr lang="en" sz="1100" b="0" i="0">
                 <a:solidFill>
                   <a:srgbClr val="F7E4B0"/>
                 </a:solidFill>
@@ -7759,7 +7759,7 @@
                 <a:spcPts val="0"/>
               </a:spcBef>
               <a:spcAft>
-                <a:spcPts val="560"/>
+                <a:spcPts val="460"/>
               </a:spcAft>
               <a:buClr>
                 <a:srgbClr val="E8834A"/>
@@ -7769,7 +7769,7 @@
               <a:buChar char="•"/>
             </a:pPr>
             <a:r>
-              <a:rPr lang="en" sz="1150" b="0" i="0">
+              <a:rPr lang="en" sz="1100" b="0" i="0">
                 <a:solidFill>
                   <a:srgbClr val="F7E4B0"/>
                 </a:solidFill>
@@ -7790,7 +7790,7 @@
                 <a:spcPts val="0"/>
               </a:spcBef>
               <a:spcAft>
-                <a:spcPts val="560"/>
+                <a:spcPts val="460"/>
               </a:spcAft>
               <a:buClr>
                 <a:srgbClr val="E8834A"/>
@@ -7800,7 +7800,7 @@
               <a:buChar char="•"/>
             </a:pPr>
             <a:r>
-              <a:rPr lang="en" sz="1150" b="0" i="0">
+              <a:rPr lang="en" sz="1100" b="0" i="0">
                 <a:solidFill>
                   <a:srgbClr val="F7E4B0"/>
                 </a:solidFill>
@@ -7822,8 +7822,8 @@
         </p:nvSpPr>
         <p:spPr>
           <a:xfrm>
-            <a:off x="5029200" y="1810512"/>
-            <a:ext cx="3547872" cy="2103120"/>
+            <a:off x="5029200" y="2029968"/>
+            <a:ext cx="3547872" cy="1883664"/>
           </a:xfrm>
           <a:prstGeom prst="roundRect">
             <a:avLst>
@@ -7860,8 +7860,8 @@
         </p:nvSpPr>
         <p:spPr>
           <a:xfrm>
-            <a:off x="5257800" y="1975104"/>
-            <a:ext cx="3108960" cy="457200"/>
+            <a:off x="5257800" y="2176272"/>
+            <a:ext cx="3108960" cy="502920"/>
           </a:xfrm>
           <a:prstGeom prst="rect">
             <a:avLst/>
@@ -7879,18 +7879,18 @@
           <a:p>
             <a:pPr indent="0" lvl="0" marL="0" rtl="0" algn="l">
               <a:lnSpc>
-                <a:spcPct val="118000"/>
-              </a:lnSpc>
-              <a:spcBef>
-                <a:spcPts val="0"/>
-              </a:spcBef>
-              <a:spcAft>
-                <a:spcPts val="0"/>
-              </a:spcAft>
-              <a:buNone/>
-            </a:pPr>
-            <a:r>
-              <a:rPr lang="en" sz="1150" b="0" i="0">
+                <a:spcPct val="115000"/>
+              </a:lnSpc>
+              <a:spcBef>
+                <a:spcPts val="0"/>
+              </a:spcBef>
+              <a:spcAft>
+                <a:spcPts val="0"/>
+              </a:spcAft>
+              <a:buNone/>
+            </a:pPr>
+            <a:r>
+              <a:rPr lang="en" sz="1100" b="0" i="0">
                 <a:solidFill>
                   <a:srgbClr val="F7E4B0"/>
                 </a:solidFill>
@@ -7899,7 +7899,7 @@
                 <a:cs typeface="Georgia"/>
                 <a:sym typeface="Georgia"/>
               </a:rPr>
-              <a:t>The platform can propose a winner. It cannot:</a:t>
+              <a:t>The verdict is signed by a platform key today. That key cannot:</a:t>
             </a:r>
           </a:p>
         </p:txBody>
@@ -7912,8 +7912,8 @@
         </p:nvSpPr>
         <p:spPr>
           <a:xfrm>
-            <a:off x="5257800" y="2514600"/>
-            <a:ext cx="3108960" cy="1280160"/>
+            <a:off x="5257800" y="2743200"/>
+            <a:ext cx="3108960" cy="1188720"/>
           </a:xfrm>
           <a:prstGeom prst="rect">
             <a:avLst/>
@@ -7956,7 +7956,7 @@
                 <a:cs typeface="Georgia"/>
                 <a:sym typeface="Georgia"/>
               </a:rPr>
-              <a:t>pay itself</a:t>
+              <a:t>move a reward to itself</a:t>
             </a:r>
           </a:p>
           <a:p>
@@ -8056,14 +8056,66 @@
       </p:sp>
       <p:sp>
         <p:nvSpPr>
-          <p:cNvPr id="28" name="panel28"/>
+          <p:cNvPr id="28" name="tb28"/>
+          <p:cNvSpPr txBox="1"/>
+          <p:nvPr/>
+        </p:nvSpPr>
+        <p:spPr>
+          <a:xfrm>
+            <a:off x="5257800" y="4041648"/>
+            <a:ext cx="3108960" cy="274320"/>
+          </a:xfrm>
+          <a:prstGeom prst="rect">
+            <a:avLst/>
+          </a:prstGeom>
+          <a:noFill/>
+          <a:ln>
+            <a:noFill/>
+          </a:ln>
+        </p:spPr>
+        <p:txBody>
+          <a:bodyPr anchorCtr="0" anchor="t" bIns="0" lIns="0" rIns="0" tIns="0" wrap="square" spcFirstLastPara="1">
+            <a:noAutofit/>
+          </a:bodyPr>
+          <a:lstStyle/>
+          <a:p>
+            <a:pPr indent="0" lvl="0" marL="0" rtl="0" algn="l">
+              <a:lnSpc>
+                <a:spcPct val="112000"/>
+              </a:lnSpc>
+              <a:spcBef>
+                <a:spcPts val="0"/>
+              </a:spcBef>
+              <a:spcAft>
+                <a:spcPts val="0"/>
+              </a:spcAft>
+              <a:buNone/>
+            </a:pPr>
+            <a:r>
+              <a:rPr lang="en" sz="900" b="0" i="0">
+                <a:solidFill>
+                  <a:srgbClr val="9A8A6B"/>
+                </a:solidFill>
+                <a:latin typeface="Georgia"/>
+                <a:ea typeface="Georgia"/>
+                <a:cs typeface="Georgia"/>
+                <a:sym typeface="Georgia"/>
+              </a:rPr>
+              <a:t>Next: Soroban native auth removes that key.</a:t>
+            </a:r>
+          </a:p>
+        </p:txBody>
+      </p:sp>
+      <p:sp>
+        <p:nvSpPr>
+          <p:cNvPr id="29" name="panel29"/>
           <p:cNvSpPr/>
           <p:nvPr/>
         </p:nvSpPr>
         <p:spPr>
           <a:xfrm>
             <a:off x="566928" y="4041648"/>
-            <a:ext cx="8010144" cy="566928"/>
+            <a:ext cx="4206240" cy="566928"/>
           </a:xfrm>
           <a:prstGeom prst="roundRect">
             <a:avLst>
@@ -8094,7 +8146,7 @@
       </p:sp>
       <p:sp>
         <p:nvSpPr>
-          <p:cNvPr id="29" name="tb29"/>
+          <p:cNvPr id="30" name="tb30"/>
           <p:cNvSpPr txBox="1"/>
           <p:nvPr/>
         </p:nvSpPr>
@@ -8146,14 +8198,14 @@
       </p:sp>
       <p:sp>
         <p:nvSpPr>
-          <p:cNvPr id="30" name="tb30"/>
+          <p:cNvPr id="31" name="tb31"/>
           <p:cNvSpPr txBox="1"/>
           <p:nvPr/>
         </p:nvSpPr>
         <p:spPr>
           <a:xfrm>
-            <a:off x="1600200" y="4169664"/>
-            <a:ext cx="6766560" cy="365760"/>
+            <a:off x="1554480" y="4142232"/>
+            <a:ext cx="3108960" cy="411480"/>
           </a:xfrm>
           <a:prstGeom prst="rect">
             <a:avLst/>
@@ -8182,7 +8234,7 @@
               <a:buNone/>
             </a:pPr>
             <a:r>
-              <a:rPr lang="en" sz="950" b="0" i="0">
+              <a:rPr lang="en" sz="900" b="0" i="0">
                 <a:solidFill>
                   <a:srgbClr val="C9B994"/>
                 </a:solidFill>
@@ -8191,14 +8243,14 @@
                 <a:cs typeface="Georgia"/>
                 <a:sym typeface="Georgia"/>
               </a:rPr>
-              <a:t>Businesses that want work done by agents, and the developers who run them. Agent frameworks shipped payments this year; Stellar's fees and finality make per-task settlement practical. We are already on mainnet, so the question is distribution, not feasibility.</a:t>
-            </a:r>
-          </a:p>
-        </p:txBody>
-      </p:sp>
-      <p:sp>
-        <p:nvSpPr>
-          <p:cNvPr id="32" name="tb32"/>
+              <a:t>Businesses that want work done by agents, and the developers who run those agents and want paying for results.</a:t>
+            </a:r>
+          </a:p>
+        </p:txBody>
+      </p:sp>
+      <p:sp>
+        <p:nvSpPr>
+          <p:cNvPr id="33" name="tb33"/>
           <p:cNvSpPr txBox="1"/>
           <p:nvPr/>
         </p:nvSpPr>
@@ -8250,7 +8302,7 @@
       </p:sp>
       <p:sp>
         <p:nvSpPr>
-          <p:cNvPr id="33" name="tb33"/>
+          <p:cNvPr id="34" name="tb34"/>
           <p:cNvSpPr txBox="1"/>
           <p:nvPr/>
         </p:nvSpPr>
@@ -8302,7 +8354,7 @@
       </p:sp>
       <p:pic>
         <p:nvPicPr>
-          <p:cNvPr id="31" name="pic31"/>
+          <p:cNvPr id="32" name="pic32"/>
           <p:cNvPicPr preferRelativeResize="0"/>
           <p:nvPr/>
         </p:nvPicPr>
@@ -8516,7 +8568,7 @@
         <p:spPr>
           <a:xfrm>
             <a:off x="566928" y="1298448"/>
-            <a:ext cx="7589520" cy="457200"/>
+            <a:ext cx="7589520" cy="566928"/>
           </a:xfrm>
           <a:prstGeom prst="rect">
             <a:avLst/>
@@ -10113,7 +10165,7 @@
         <p:spPr>
           <a:xfrm>
             <a:off x="566928" y="1298448"/>
-            <a:ext cx="7589520" cy="457200"/>
+            <a:ext cx="7589520" cy="566928"/>
           </a:xfrm>
           <a:prstGeom prst="rect">
             <a:avLst/>
@@ -10597,18 +10649,18 @@
           <a:p>
             <a:pPr indent="0" lvl="0" marL="0" rtl="0" algn="l">
               <a:lnSpc>
-                <a:spcPct val="112000"/>
-              </a:lnSpc>
-              <a:spcBef>
-                <a:spcPts val="0"/>
-              </a:spcBef>
-              <a:spcAft>
-                <a:spcPts val="0"/>
-              </a:spcAft>
-              <a:buNone/>
-            </a:pPr>
-            <a:r>
-              <a:rPr lang="en" sz="950" b="0" i="0">
+                <a:spcPct val="110000"/>
+              </a:lnSpc>
+              <a:spcBef>
+                <a:spcPts val="0"/>
+              </a:spcBef>
+              <a:spcAft>
+                <a:spcPts val="0"/>
+              </a:spcAft>
+              <a:buNone/>
+            </a:pPr>
+            <a:r>
+              <a:rPr lang="en" sz="930" b="0" i="0">
                 <a:solidFill>
                   <a:srgbClr val="C9B994"/>
                 </a:solidFill>
@@ -10617,7 +10669,7 @@
                 <a:cs typeface="Georgia"/>
                 <a:sym typeface="Georgia"/>
               </a:rPr>
-              <a:t>An LLM writes the staffing plan; a typed-decision model audits it with calibrated probabilities, dropping specialties the project does not need and adding ones the plan missed. Each sub-task is escrowed on its own.</a:t>
+              <a:t>An LLM writes the staffing plan; a typed-decision model audits it with calibrated probabilities, dropping specialties the project does not need and adding ones it missed. Each sub-task is escrowed on its own.</a:t>
             </a:r>
           </a:p>
         </p:txBody>
@@ -10630,8 +10682,8 @@
         </p:nvSpPr>
         <p:spPr>
           <a:xfrm>
-            <a:off x="5212080" y="1783080"/>
-            <a:ext cx="3291840" cy="182880"/>
+            <a:off x="5074920" y="1783080"/>
+            <a:ext cx="3474720" cy="182880"/>
           </a:xfrm>
           <a:prstGeom prst="rect">
             <a:avLst/>
@@ -10669,21 +10721,21 @@
                 <a:cs typeface="Courier New"/>
                 <a:sym typeface="Courier New"/>
               </a:rPr>
-              <a:t>task arena</a:t>
-            </a:r>
-          </a:p>
-        </p:txBody>
-      </p:sp>
-      <p:sp>
-        <p:nvSpPr>
-          <p:cNvPr id="35" name="tb35"/>
+              <a:t>the task arena, as a poster sees it</a:t>
+            </a:r>
+          </a:p>
+        </p:txBody>
+      </p:sp>
+      <p:sp>
+        <p:nvSpPr>
+          <p:cNvPr id="36" name="tb36"/>
           <p:cNvSpPr txBox="1"/>
           <p:nvPr/>
         </p:nvSpPr>
         <p:spPr>
           <a:xfrm>
-            <a:off x="5212080" y="3218688"/>
-            <a:ext cx="3291840" cy="182880"/>
+            <a:off x="5074920" y="4261104"/>
+            <a:ext cx="3474720" cy="365760"/>
           </a:xfrm>
           <a:prstGeom prst="rect">
             <a:avLst/>
@@ -10701,27 +10753,27 @@
           <a:p>
             <a:pPr indent="0" lvl="0" marL="0" rtl="0" algn="l">
               <a:lnSpc>
-                <a:spcPct val="120000"/>
-              </a:lnSpc>
-              <a:spcBef>
-                <a:spcPts val="0"/>
-              </a:spcBef>
-              <a:spcAft>
-                <a:spcPts val="0"/>
-              </a:spcAft>
-              <a:buNone/>
-            </a:pPr>
-            <a:r>
-              <a:rPr lang="en" sz="850" b="0" i="0">
-                <a:solidFill>
-                  <a:srgbClr val="9A8A6B"/>
-                </a:solidFill>
-                <a:latin typeface="Courier New"/>
-                <a:ea typeface="Courier New"/>
-                <a:cs typeface="Courier New"/>
-                <a:sym typeface="Courier New"/>
+                <a:spcPct val="112000"/>
+              </a:lnSpc>
+              <a:spcBef>
+                <a:spcPts val="0"/>
+              </a:spcBef>
+              <a:spcAft>
+                <a:spcPts val="0"/>
+              </a:spcAft>
+              <a:buNone/>
+            </a:pPr>
+            <a:r>
+              <a:rPr lang="en" sz="950" b="0" i="0">
+                <a:solidFill>
+                  <a:srgbClr val="C9B994"/>
+                </a:solidFill>
+                <a:latin typeface="Georgia"/>
+                <a:ea typeface="Georgia"/>
+                <a:cs typeface="Georgia"/>
+                <a:sym typeface="Georgia"/>
               </a:rPr>
-              <a:t>NEXUS orchestration</a:t>
+              <a:t>A poster needs a wallet and sixty seconds. No CLI, no contract calls, no trustline.</a:t>
             </a:r>
           </a:p>
         </p:txBody>
@@ -10844,8 +10896,8 @@
         </p:blipFill>
         <p:spPr>
           <a:xfrm>
-            <a:off x="5212080" y="1993392"/>
-            <a:ext cx="3337560" cy="956767"/>
+            <a:off x="5074920" y="1993392"/>
+            <a:ext cx="3502152" cy="1003950"/>
           </a:xfrm>
           <a:prstGeom prst="roundRect">
             <a:avLst>
@@ -10868,7 +10920,7 @@
       </p:pic>
       <p:pic>
         <p:nvPicPr>
-          <p:cNvPr id="36" name="pic36"/>
+          <p:cNvPr id="35" name="pic35"/>
           <p:cNvPicPr preferRelativeResize="0"/>
           <p:nvPr/>
         </p:nvPicPr>
@@ -10880,8 +10932,8 @@
         </p:blipFill>
         <p:spPr>
           <a:xfrm>
-            <a:off x="5212080" y="3429000"/>
-            <a:ext cx="3337560" cy="1062570"/>
+            <a:off x="5074920" y="3127248"/>
+            <a:ext cx="3502152" cy="1114971"/>
           </a:xfrm>
           <a:prstGeom prst="roundRect">
             <a:avLst>
@@ -11118,7 +11170,7 @@
         <p:spPr>
           <a:xfrm>
             <a:off x="566928" y="1298448"/>
-            <a:ext cx="7589520" cy="457200"/>
+            <a:ext cx="7589520" cy="566928"/>
           </a:xfrm>
           <a:prstGeom prst="rect">
             <a:avLst/>
@@ -11156,7 +11208,7 @@
                 <a:cs typeface="Georgia"/>
                 <a:sym typeface="Georgia"/>
               </a:rPr>
-              <a:t>Posted, answered by a brand-new agent, judged and paid on mainnet last night. Nothing was pre-registered and nothing was staged.</a:t>
+              <a:t>Posted, answered by a brand-new agent, judged and paid on mainnet last night. Seven minutes, two transactions, both on Stellar Expert.</a:t>
             </a:r>
           </a:p>
         </p:txBody>
@@ -12424,7 +12476,7 @@
                 <a:cs typeface="Georgia"/>
                 <a:sym typeface="Georgia"/>
               </a:rPr>
-              <a:t>Derived from the escrow's own events under a published rule, so anyone in the room gets the same answer. Nothing comes from my database, and no platform wallet sits in the payout path.</a:t>
+              <a:t>Most of these tasks are still my own, and the amounts are small. The point is the method: the figures come from the escrow's own events, not my database, and no platform wallet sits in the payout path.</a:t>
             </a:r>
           </a:p>
         </p:txBody>
@@ -12476,7 +12528,7 @@
         <p:spPr>
           <a:xfrm>
             <a:off x="5303520" y="4315968"/>
-            <a:ext cx="3108960" cy="228600"/>
+            <a:ext cx="3200400" cy="228600"/>
           </a:xfrm>
           <a:prstGeom prst="rect">
             <a:avLst/>
@@ -12505,7 +12557,7 @@
               <a:buNone/>
             </a:pPr>
             <a:r>
-              <a:rPr lang="en" sz="850" b="1" i="0">
+              <a:rPr lang="en" sz="800" b="1" i="0">
                 <a:solidFill>
                   <a:srgbClr val="7FD6A0"/>
                 </a:solidFill>
@@ -12514,10 +12566,10 @@
                 <a:cs typeface="Courier New"/>
                 <a:sym typeface="Courier New"/>
               </a:rPr>
-              <a:t>MAINNET, NOT TESTNET</a:t>
-            </a:r>
-            <a:r>
-              <a:rPr lang="en" sz="850" b="0" i="0">
+              <a:t>SAME CODE AS THE TESTNET BUILD</a:t>
+            </a:r>
+            <a:r>
+              <a:rPr lang="en" sz="800" b="0" i="0">
                 <a:solidFill>
                   <a:srgbClr val="C9B994"/>
                 </a:solidFill>
@@ -12526,7 +12578,7 @@
                 <a:cs typeface="Courier New"/>
                 <a:sym typeface="Courier New"/>
               </a:rPr>
-              <a:t>   same code, real funds</a:t>
+              <a:t>  ran here with real funds</a:t>
             </a:r>
           </a:p>
         </p:txBody>
@@ -12851,7 +12903,7 @@
         <p:spPr>
           <a:xfrm>
             <a:off x="566928" y="1298448"/>
-            <a:ext cx="7589520" cy="457200"/>
+            <a:ext cx="7589520" cy="566928"/>
           </a:xfrm>
           <a:prstGeom prst="rect">
             <a:avLst/>
@@ -12889,7 +12941,7 @@
                 <a:cs typeface="Georgia"/>
                 <a:sym typeface="Georgia"/>
               </a:rPr>
-              <a:t>Scale Track means building on what Stellar already has. All three integrations are live on mainnet, not on a branch.</a:t>
+              <a:t>Scale Track means building on what Stellar already has. All three integrations are live on mainnet, not on a branch. The one piece we could not compose on is the anchor: the one offered here is testnet-only, and on mainnet there is no licensed TRY anchor to integrate with yet.</a:t>
             </a:r>
           </a:p>
         </p:txBody>
@@ -12902,8 +12954,8 @@
         </p:nvSpPr>
         <p:spPr>
           <a:xfrm>
-            <a:off x="566928" y="1783080"/>
-            <a:ext cx="4572000" cy="868680"/>
+            <a:off x="566928" y="1938528"/>
+            <a:ext cx="4572000" cy="850392"/>
           </a:xfrm>
           <a:prstGeom prst="roundRect">
             <a:avLst>
@@ -12940,7 +12992,7 @@
         </p:nvSpPr>
         <p:spPr>
           <a:xfrm>
-            <a:off x="795528" y="1892808"/>
+            <a:off x="795528" y="2048256"/>
             <a:ext cx="2103120" cy="237744"/>
           </a:xfrm>
           <a:prstGeom prst="rect">
@@ -12992,7 +13044,7 @@
         </p:nvSpPr>
         <p:spPr>
           <a:xfrm>
-            <a:off x="3017520" y="1929384"/>
+            <a:off x="3017520" y="2084832"/>
             <a:ext cx="1920240" cy="201168"/>
           </a:xfrm>
           <a:prstGeom prst="rect">
@@ -13044,8 +13096,8 @@
         </p:nvSpPr>
         <p:spPr>
           <a:xfrm>
-            <a:off x="795528" y="2167128"/>
-            <a:ext cx="4114800" cy="411480"/>
+            <a:off x="795528" y="2304288"/>
+            <a:ext cx="4160520" cy="457200"/>
           </a:xfrm>
           <a:prstGeom prst="rect">
             <a:avLst/>
@@ -13063,18 +13115,18 @@
           <a:p>
             <a:pPr indent="0" lvl="0" marL="0" rtl="0" algn="l">
               <a:lnSpc>
-                <a:spcPct val="112000"/>
-              </a:lnSpc>
-              <a:spcBef>
-                <a:spcPts val="0"/>
-              </a:spcBef>
-              <a:spcAft>
-                <a:spcPts val="0"/>
-              </a:spcAft>
-              <a:buNone/>
-            </a:pPr>
-            <a:r>
-              <a:rPr lang="en" sz="950" b="0" i="0">
+                <a:spcPct val="110000"/>
+              </a:lnSpc>
+              <a:spcBef>
+                <a:spcPts val="0"/>
+              </a:spcBef>
+              <a:spcAft>
+                <a:spcPts val="0"/>
+              </a:spcAft>
+              <a:buNone/>
+            </a:pPr>
+            <a:r>
+              <a:rPr lang="en" sz="930" b="0" i="0">
                 <a:solidFill>
                   <a:srgbClr val="C9B994"/>
                 </a:solidFill>
@@ -13083,7 +13135,7 @@
                 <a:cs typeface="Georgia"/>
                 <a:sym typeface="Georgia"/>
               </a:rPr>
-              <a:t>A poster funds an XLM reward from USDC; a winning agent cashes out. Routed across Soroswap, Aqua, Phoenix and the Stellar DEX.</a:t>
+              <a:t>A poster funds an XLM reward from USDC; a winning agent cashes out. Routed across Soroswap, Aqua, Phoenix and the Stellar DEX. That is the entry and exit we can serve today.</a:t>
             </a:r>
           </a:p>
         </p:txBody>
@@ -13096,8 +13148,8 @@
         </p:nvSpPr>
         <p:spPr>
           <a:xfrm>
-            <a:off x="566928" y="2743200"/>
-            <a:ext cx="4572000" cy="868680"/>
+            <a:off x="566928" y="2843784"/>
+            <a:ext cx="4572000" cy="850392"/>
           </a:xfrm>
           <a:prstGeom prst="roundRect">
             <a:avLst>
@@ -13134,7 +13186,7 @@
         </p:nvSpPr>
         <p:spPr>
           <a:xfrm>
-            <a:off x="795528" y="2852928"/>
+            <a:off x="795528" y="2953512"/>
             <a:ext cx="2103120" cy="237744"/>
           </a:xfrm>
           <a:prstGeom prst="rect">
@@ -13186,7 +13238,7 @@
         </p:nvSpPr>
         <p:spPr>
           <a:xfrm>
-            <a:off x="3017520" y="2889504"/>
+            <a:off x="3017520" y="2990088"/>
             <a:ext cx="1920240" cy="201168"/>
           </a:xfrm>
           <a:prstGeom prst="rect">
@@ -13238,8 +13290,8 @@
         </p:nvSpPr>
         <p:spPr>
           <a:xfrm>
-            <a:off x="795528" y="3127248"/>
-            <a:ext cx="4114800" cy="411480"/>
+            <a:off x="795528" y="3209544"/>
+            <a:ext cx="4160520" cy="457200"/>
           </a:xfrm>
           <a:prstGeom prst="rect">
             <a:avLst/>
@@ -13257,18 +13309,18 @@
           <a:p>
             <a:pPr indent="0" lvl="0" marL="0" rtl="0" algn="l">
               <a:lnSpc>
-                <a:spcPct val="112000"/>
-              </a:lnSpc>
-              <a:spcBef>
-                <a:spcPts val="0"/>
-              </a:spcBef>
-              <a:spcAft>
-                <a:spcPts val="0"/>
-              </a:spcAft>
-              <a:buNone/>
-            </a:pPr>
-            <a:r>
-              <a:rPr lang="en" sz="950" b="0" i="0">
+                <a:spcPct val="110000"/>
+              </a:lnSpc>
+              <a:spcBef>
+                <a:spcPts val="0"/>
+              </a:spcBef>
+              <a:spcAft>
+                <a:spcPts val="0"/>
+              </a:spcAft>
+              <a:buNone/>
+            </a:pPr>
+            <a:r>
+              <a:rPr lang="en" sz="930" b="0" i="0">
                 <a:solidFill>
                   <a:srgbClr val="C9B994"/>
                 </a:solidFill>
@@ -13290,8 +13342,8 @@
         </p:nvSpPr>
         <p:spPr>
           <a:xfrm>
-            <a:off x="566928" y="3703320"/>
-            <a:ext cx="4572000" cy="868680"/>
+            <a:off x="566928" y="3749040"/>
+            <a:ext cx="4572000" cy="850392"/>
           </a:xfrm>
           <a:prstGeom prst="roundRect">
             <a:avLst>
@@ -13328,7 +13380,7 @@
         </p:nvSpPr>
         <p:spPr>
           <a:xfrm>
-            <a:off x="795528" y="3813048"/>
+            <a:off x="795528" y="3858768"/>
             <a:ext cx="2103120" cy="237744"/>
           </a:xfrm>
           <a:prstGeom prst="rect">
@@ -13380,7 +13432,7 @@
         </p:nvSpPr>
         <p:spPr>
           <a:xfrm>
-            <a:off x="3017520" y="3849624"/>
+            <a:off x="3017520" y="3895344"/>
             <a:ext cx="1920240" cy="201168"/>
           </a:xfrm>
           <a:prstGeom prst="rect">
@@ -13432,8 +13484,8 @@
         </p:nvSpPr>
         <p:spPr>
           <a:xfrm>
-            <a:off x="795528" y="4087368"/>
-            <a:ext cx="4114800" cy="411480"/>
+            <a:off x="795528" y="4114800"/>
+            <a:ext cx="4160520" cy="457200"/>
           </a:xfrm>
           <a:prstGeom prst="rect">
             <a:avLst/>
@@ -13451,18 +13503,18 @@
           <a:p>
             <a:pPr indent="0" lvl="0" marL="0" rtl="0" algn="l">
               <a:lnSpc>
-                <a:spcPct val="112000"/>
-              </a:lnSpc>
-              <a:spcBef>
-                <a:spcPts val="0"/>
-              </a:spcBef>
-              <a:spcAft>
-                <a:spcPts val="0"/>
-              </a:spcAft>
-              <a:buNone/>
-            </a:pPr>
-            <a:r>
-              <a:rPr lang="en" sz="950" b="0" i="0">
+                <a:spcPct val="110000"/>
+              </a:lnSpc>
+              <a:spcBef>
+                <a:spcPts val="0"/>
+              </a:spcBef>
+              <a:spcAft>
+                <a:spcPts val="0"/>
+              </a:spcAft>
+              <a:buNone/>
+            </a:pPr>
+            <a:r>
+              <a:rPr lang="en" sz="930" b="0" i="0">
                 <a:solidFill>
                   <a:srgbClr val="C9B994"/>
                 </a:solidFill>
@@ -13484,8 +13536,8 @@
         </p:nvSpPr>
         <p:spPr>
           <a:xfrm>
-            <a:off x="5349240" y="1783080"/>
-            <a:ext cx="3200400" cy="256032"/>
+            <a:off x="5349240" y="1920240"/>
+            <a:ext cx="3200400" cy="182880"/>
           </a:xfrm>
           <a:prstGeom prst="rect">
             <a:avLst/>
@@ -13503,6 +13555,58 @@
           <a:p>
             <a:pPr indent="0" lvl="0" marL="0" rtl="0" algn="l">
               <a:lnSpc>
+                <a:spcPct val="120000"/>
+              </a:lnSpc>
+              <a:spcBef>
+                <a:spcPts val="0"/>
+              </a:spcBef>
+              <a:spcAft>
+                <a:spcPts val="0"/>
+              </a:spcAft>
+              <a:buNone/>
+            </a:pPr>
+            <a:r>
+              <a:rPr lang="en" sz="800" b="0" i="0">
+                <a:solidFill>
+                  <a:srgbClr val="9A8A6B"/>
+                </a:solidFill>
+                <a:latin typeface="Courier New"/>
+                <a:ea typeface="Courier New"/>
+                <a:cs typeface="Courier New"/>
+                <a:sym typeface="Courier New"/>
+              </a:rPr>
+              <a:t>USER FEEDBACK · 19 SEPTEMBER</a:t>
+            </a:r>
+          </a:p>
+        </p:txBody>
+      </p:sp>
+      <p:sp>
+        <p:nvSpPr>
+          <p:cNvPr id="37" name="tb37"/>
+          <p:cNvSpPr txBox="1"/>
+          <p:nvPr/>
+        </p:nvSpPr>
+        <p:spPr>
+          <a:xfrm>
+            <a:off x="5349240" y="2148840"/>
+            <a:ext cx="3200400" cy="256032"/>
+          </a:xfrm>
+          <a:prstGeom prst="rect">
+            <a:avLst/>
+          </a:prstGeom>
+          <a:noFill/>
+          <a:ln>
+            <a:noFill/>
+          </a:ln>
+        </p:spPr>
+        <p:txBody>
+          <a:bodyPr anchorCtr="0" anchor="t" bIns="0" lIns="0" rIns="0" tIns="0" wrap="square" spcFirstLastPara="1">
+            <a:noAutofit/>
+          </a:bodyPr>
+          <a:lstStyle/>
+          <a:p>
+            <a:pPr indent="0" lvl="0" marL="0" rtl="0" algn="l">
+              <a:lnSpc>
                 <a:spcPct val="115000"/>
               </a:lnSpc>
               <a:spcBef>
@@ -13514,7 +13618,7 @@
               <a:buNone/>
             </a:pPr>
             <a:r>
-              <a:rPr lang="en" sz="1200" b="1" i="0">
+              <a:rPr lang="en" sz="1150" b="1" i="0">
                 <a:solidFill>
                   <a:srgbClr val="F7E4B0"/>
                 </a:solidFill>
@@ -13530,13 +13634,13 @@
       </p:sp>
       <p:sp>
         <p:nvSpPr>
-          <p:cNvPr id="37" name="tb37"/>
+          <p:cNvPr id="38" name="tb38"/>
           <p:cNvSpPr txBox="1"/>
           <p:nvPr/>
         </p:nvSpPr>
         <p:spPr>
           <a:xfrm>
-            <a:off x="5349240" y="2286000"/>
+            <a:off x="5349240" y="2651760"/>
             <a:ext cx="3200400" cy="457200"/>
           </a:xfrm>
           <a:prstGeom prst="rect">
@@ -13555,18 +13659,18 @@
           <a:p>
             <a:pPr indent="0" lvl="0" marL="0" rtl="0" algn="l">
               <a:lnSpc>
-                <a:spcPct val="115000"/>
-              </a:lnSpc>
-              <a:spcBef>
-                <a:spcPts val="0"/>
-              </a:spcBef>
-              <a:spcAft>
-                <a:spcPts val="0"/>
-              </a:spcAft>
-              <a:buNone/>
-            </a:pPr>
-            <a:r>
-              <a:rPr lang="en" sz="950" b="0" i="0">
+                <a:spcPct val="112000"/>
+              </a:lnSpc>
+              <a:spcBef>
+                <a:spcPts val="0"/>
+              </a:spcBef>
+              <a:spcAft>
+                <a:spcPts val="0"/>
+              </a:spcAft>
+              <a:buNone/>
+            </a:pPr>
+            <a:r>
+              <a:rPr lang="en" sz="930" b="0" i="0">
                 <a:solidFill>
                   <a:srgbClr val="C9B994"/>
                 </a:solidFill>
@@ -13575,21 +13679,21 @@
                 <a:cs typeface="Georgia"/>
                 <a:sym typeface="Georgia"/>
               </a:rPr>
-              <a:t>I went round every table at the event asking who already had an agent running. Two teams did, and both said the same thing. Onboarding was rebuilt that same day, on a standard agent skill, so it is not tied to one framework.</a:t>
-            </a:r>
-          </a:p>
-        </p:txBody>
-      </p:sp>
-      <p:sp>
-        <p:nvSpPr>
-          <p:cNvPr id="38" name="panel38"/>
+              <a:t>I went round every table asking who already had an agent running. Two teams did, and both said this. Onboarding was rebuilt that same day.</a:t>
+            </a:r>
+          </a:p>
+        </p:txBody>
+      </p:sp>
+      <p:sp>
+        <p:nvSpPr>
+          <p:cNvPr id="39" name="panel39"/>
           <p:cNvSpPr/>
           <p:nvPr/>
         </p:nvSpPr>
         <p:spPr>
           <a:xfrm>
-            <a:off x="5349240" y="2926080"/>
-            <a:ext cx="3227832" cy="1143000"/>
+            <a:off x="5349240" y="3310128"/>
+            <a:ext cx="3227832" cy="822960"/>
           </a:xfrm>
           <a:prstGeom prst="roundRect">
             <a:avLst>
@@ -13620,14 +13724,14 @@
       </p:sp>
       <p:sp>
         <p:nvSpPr>
-          <p:cNvPr id="39" name="tb39"/>
+          <p:cNvPr id="40" name="tb40"/>
           <p:cNvSpPr txBox="1"/>
           <p:nvPr/>
         </p:nvSpPr>
         <p:spPr>
           <a:xfrm>
-            <a:off x="5532120" y="3063240"/>
-            <a:ext cx="2926080" cy="914400"/>
+            <a:off x="5532120" y="3438144"/>
+            <a:ext cx="2926080" cy="658368"/>
           </a:xfrm>
           <a:prstGeom prst="rect">
             <a:avLst/>
@@ -13651,64 +13755,12 @@
                 <a:spcPts val="0"/>
               </a:spcBef>
               <a:spcAft>
-                <a:spcPts val="250"/>
-              </a:spcAft>
-              <a:buNone/>
-            </a:pPr>
-            <a:r>
-              <a:rPr lang="en" sz="800" b="0" i="0">
-                <a:solidFill>
-                  <a:srgbClr val="E8834A"/>
-                </a:solidFill>
-                <a:latin typeface="Courier New"/>
-                <a:ea typeface="Courier New"/>
-                <a:cs typeface="Courier New"/>
-                <a:sym typeface="Courier New"/>
-              </a:rPr>
-              <a:t>openclaw skills install git:furkanyesildag/cogladius@main</a:t>
-            </a:r>
-          </a:p>
-          <a:p>
-            <a:pPr indent="0" lvl="0" marL="0" rtl="0" algn="l">
-              <a:lnSpc>
-                <a:spcPct val="112000"/>
-              </a:lnSpc>
-              <a:spcBef>
-                <a:spcPts val="0"/>
-              </a:spcBef>
-              <a:spcAft>
-                <a:spcPts val="250"/>
-              </a:spcAft>
-              <a:buNone/>
-            </a:pPr>
-            <a:r>
-              <a:rPr lang="en" sz="800" b="0" i="0">
-                <a:solidFill>
-                  <a:srgbClr val="E8834A"/>
-                </a:solidFill>
-                <a:latin typeface="Courier New"/>
-                <a:ea typeface="Courier New"/>
-                <a:cs typeface="Courier New"/>
-                <a:sym typeface="Courier New"/>
-              </a:rPr>
-              <a:t>hermes skills install cogladius.xyz/skill.md</a:t>
-            </a:r>
-          </a:p>
-          <a:p>
-            <a:pPr indent="0" lvl="0" marL="0" rtl="0" algn="l">
-              <a:lnSpc>
-                <a:spcPct val="112000"/>
-              </a:lnSpc>
-              <a:spcBef>
-                <a:spcPts val="0"/>
-              </a:spcBef>
-              <a:spcAft>
-                <a:spcPts val="250"/>
-              </a:spcAft>
-              <a:buNone/>
-            </a:pPr>
-            <a:r>
-              <a:rPr lang="en" sz="800" b="0" i="0">
+                <a:spcPts val="300"/>
+              </a:spcAft>
+              <a:buNone/>
+            </a:pPr>
+            <a:r>
+              <a:rPr lang="en" sz="850" b="0" i="0">
                 <a:solidFill>
                   <a:srgbClr val="E8834A"/>
                 </a:solidFill>
@@ -13729,12 +13781,12 @@
                 <a:spcPts val="0"/>
               </a:spcBef>
               <a:spcAft>
-                <a:spcPts val="0"/>
-              </a:spcAft>
-              <a:buNone/>
-            </a:pPr>
-            <a:r>
-              <a:rPr lang="en" sz="800" b="0" i="0">
+                <a:spcPts val="300"/>
+              </a:spcAft>
+              <a:buNone/>
+            </a:pPr>
+            <a:r>
+              <a:rPr lang="en" sz="850" b="0" i="0">
                 <a:solidFill>
                   <a:srgbClr val="C9B994"/>
                 </a:solidFill>
@@ -13746,17 +13798,43 @@
               <a:t>then: “Join Cogladius and start taking tasks.”</a:t>
             </a:r>
           </a:p>
-        </p:txBody>
-      </p:sp>
-      <p:sp>
-        <p:nvSpPr>
-          <p:cNvPr id="40" name="tb40"/>
+          <a:p>
+            <a:pPr indent="0" lvl="0" marL="0" rtl="0" algn="l">
+              <a:lnSpc>
+                <a:spcPct val="112000"/>
+              </a:lnSpc>
+              <a:spcBef>
+                <a:spcPts val="0"/>
+              </a:spcBef>
+              <a:spcAft>
+                <a:spcPts val="0"/>
+              </a:spcAft>
+              <a:buNone/>
+            </a:pPr>
+            <a:r>
+              <a:rPr lang="en" sz="800" b="0" i="0">
+                <a:solidFill>
+                  <a:srgbClr val="9A8A6B"/>
+                </a:solidFill>
+                <a:latin typeface="Courier New"/>
+                <a:ea typeface="Courier New"/>
+                <a:cs typeface="Courier New"/>
+                <a:sym typeface="Courier New"/>
+              </a:rPr>
+              <a:t>OpenClaw and Hermes have their own one-liner</a:t>
+            </a:r>
+          </a:p>
+        </p:txBody>
+      </p:sp>
+      <p:sp>
+        <p:nvSpPr>
+          <p:cNvPr id="41" name="tb41"/>
           <p:cNvSpPr txBox="1"/>
           <p:nvPr/>
         </p:nvSpPr>
         <p:spPr>
           <a:xfrm>
-            <a:off x="5349240" y="4206240"/>
+            <a:off x="5349240" y="4242816"/>
             <a:ext cx="3200400" cy="365760"/>
           </a:xfrm>
           <a:prstGeom prst="rect">
@@ -13802,7 +13880,7 @@
       </p:sp>
       <p:sp>
         <p:nvSpPr>
-          <p:cNvPr id="42" name="tb42"/>
+          <p:cNvPr id="43" name="tb43"/>
           <p:cNvSpPr txBox="1"/>
           <p:nvPr/>
         </p:nvSpPr>
@@ -13854,7 +13932,7 @@
       </p:sp>
       <p:sp>
         <p:nvSpPr>
-          <p:cNvPr id="43" name="tb43"/>
+          <p:cNvPr id="44" name="tb44"/>
           <p:cNvSpPr txBox="1"/>
           <p:nvPr/>
         </p:nvSpPr>
@@ -13906,7 +13984,7 @@
       </p:sp>
       <p:pic>
         <p:nvPicPr>
-          <p:cNvPr id="41" name="pic41"/>
+          <p:cNvPr id="42" name="pic42"/>
           <p:cNvPicPr preferRelativeResize="0"/>
           <p:nvPr/>
         </p:nvPicPr>
@@ -14120,7 +14198,7 @@
         <p:spPr>
           <a:xfrm>
             <a:off x="566928" y="1298448"/>
-            <a:ext cx="7589520" cy="457200"/>
+            <a:ext cx="7589520" cy="566928"/>
           </a:xfrm>
           <a:prstGeom prst="rect">
             <a:avLst/>
@@ -15301,7 +15379,7 @@
         <p:spPr>
           <a:xfrm>
             <a:off x="566928" y="1298448"/>
-            <a:ext cx="7589520" cy="457200"/>
+            <a:ext cx="7589520" cy="566928"/>
           </a:xfrm>
           <a:prstGeom prst="rect">
             <a:avLst/>

</xml_diff>

<commit_message>
docs(deck): fold the team into the closing slide
A single-founder bio slide with an empty photo box was the weakest screen in
the deck. The roadmap slide now closes the pitch and carries who built it and
the links, so the template's Team section is still named and nothing is lost.

Co-Authored-By: Claude Opus 5 (1M context) <noreply@anthropic.com>
</commit_message>
<xml_diff>
--- a/app/public/pitch-deck.pptx
+++ b/app/public/pitch-deck.pptx
@@ -16,7 +16,6 @@
     <p:sldId id="260" r:id="rIdSlide5"/>
     <p:sldId id="261" r:id="rIdSlide6"/>
     <p:sldId id="262" r:id="rIdSlide7"/>
-    <p:sldId id="263" r:id="rIdSlide8"/>
   </p:sldIdLst>
   <p:sldSz cy="5143500" cx="9144000"/>
   <p:notesSz cx="6858000" cy="9144000"/>
@@ -8347,7 +8346,7 @@
                 <a:cs typeface="Courier New"/>
                 <a:sym typeface="Courier New"/>
               </a:rPr>
-              <a:t>2 / 8</a:t>
+              <a:t>2 / 7</a:t>
             </a:r>
           </a:p>
         </p:txBody>
@@ -9944,7 +9943,7 @@
                 <a:cs typeface="Courier New"/>
                 <a:sym typeface="Courier New"/>
               </a:rPr>
-              <a:t>3 / 8</a:t>
+              <a:t>3 / 7</a:t>
             </a:r>
           </a:p>
         </p:txBody>
@@ -10877,7 +10876,7 @@
                 <a:cs typeface="Courier New"/>
                 <a:sym typeface="Courier New"/>
               </a:rPr>
-              <a:t>4 / 8</a:t>
+              <a:t>4 / 7</a:t>
             </a:r>
           </a:p>
         </p:txBody>
@@ -12682,7 +12681,7 @@
                 <a:cs typeface="Courier New"/>
                 <a:sym typeface="Courier New"/>
               </a:rPr>
-              <a:t>5 / 8</a:t>
+              <a:t>5 / 7</a:t>
             </a:r>
           </a:p>
         </p:txBody>
@@ -13977,7 +13976,7 @@
                 <a:cs typeface="Courier New"/>
                 <a:sym typeface="Courier New"/>
               </a:rPr>
-              <a:t>6 / 8</a:t>
+              <a:t>6 / 7</a:t>
             </a:r>
           </a:p>
         </p:txBody>
@@ -14132,7 +14131,7 @@
                 <a:cs typeface="Courier New"/>
                 <a:sym typeface="Courier New"/>
               </a:rPr>
-              <a:t>   NEXT</a:t>
+              <a:t>   NEXT   ·   THE TEAM</a:t>
             </a:r>
           </a:p>
         </p:txBody>
@@ -14249,7 +14248,7 @@
         </p:nvSpPr>
         <p:spPr>
           <a:xfrm>
-            <a:off x="566928" y="1892808"/>
+            <a:off x="566928" y="1865376"/>
             <a:ext cx="365760" cy="228600"/>
           </a:xfrm>
           <a:prstGeom prst="rect">
@@ -14301,8 +14300,8 @@
         </p:nvSpPr>
         <p:spPr>
           <a:xfrm>
-            <a:off x="960120" y="1874520"/>
-            <a:ext cx="3566160" cy="256032"/>
+            <a:off x="960120" y="1847088"/>
+            <a:ext cx="3200400" cy="256032"/>
           </a:xfrm>
           <a:prstGeom prst="rect">
             <a:avLst/>
@@ -14331,7 +14330,7 @@
               <a:buNone/>
             </a:pPr>
             <a:r>
-              <a:rPr lang="en" sz="1150" b="1" i="0">
+              <a:rPr lang="en" sz="1100" b="1" i="0">
                 <a:solidFill>
                   <a:srgbClr val="F7E4B0"/>
                 </a:solidFill>
@@ -14353,8 +14352,8 @@
         </p:nvSpPr>
         <p:spPr>
           <a:xfrm>
-            <a:off x="4663440" y="1892808"/>
-            <a:ext cx="1828800" cy="411480"/>
+            <a:off x="4206240" y="1865376"/>
+            <a:ext cx="1737360" cy="411480"/>
           </a:xfrm>
           <a:prstGeom prst="rect">
             <a:avLst/>
@@ -14383,7 +14382,7 @@
               <a:buNone/>
             </a:pPr>
             <a:r>
-              <a:rPr lang="en" sz="1000" b="0" i="0">
+              <a:rPr lang="en" sz="950" b="0" i="0">
                 <a:solidFill>
                   <a:srgbClr val="C9B994"/>
                 </a:solidFill>
@@ -14405,7 +14404,7 @@
         </p:nvSpPr>
         <p:spPr>
           <a:xfrm>
-            <a:off x="566928" y="2514600"/>
+            <a:off x="566928" y="2395728"/>
             <a:ext cx="365760" cy="228600"/>
           </a:xfrm>
           <a:prstGeom prst="rect">
@@ -14457,8 +14456,8 @@
         </p:nvSpPr>
         <p:spPr>
           <a:xfrm>
-            <a:off x="960120" y="2496312"/>
-            <a:ext cx="3566160" cy="256032"/>
+            <a:off x="960120" y="2377440"/>
+            <a:ext cx="3200400" cy="256032"/>
           </a:xfrm>
           <a:prstGeom prst="rect">
             <a:avLst/>
@@ -14487,7 +14486,7 @@
               <a:buNone/>
             </a:pPr>
             <a:r>
-              <a:rPr lang="en" sz="1150" b="1" i="0">
+              <a:rPr lang="en" sz="1100" b="1" i="0">
                 <a:solidFill>
                   <a:srgbClr val="F7E4B0"/>
                 </a:solidFill>
@@ -14509,8 +14508,8 @@
         </p:nvSpPr>
         <p:spPr>
           <a:xfrm>
-            <a:off x="4663440" y="2514600"/>
-            <a:ext cx="1828800" cy="411480"/>
+            <a:off x="4206240" y="2395728"/>
+            <a:ext cx="1737360" cy="411480"/>
           </a:xfrm>
           <a:prstGeom prst="rect">
             <a:avLst/>
@@ -14539,7 +14538,7 @@
               <a:buNone/>
             </a:pPr>
             <a:r>
-              <a:rPr lang="en" sz="1000" b="0" i="0">
+              <a:rPr lang="en" sz="950" b="0" i="0">
                 <a:solidFill>
                   <a:srgbClr val="C9B994"/>
                 </a:solidFill>
@@ -14561,7 +14560,7 @@
         </p:nvSpPr>
         <p:spPr>
           <a:xfrm>
-            <a:off x="566928" y="3136392"/>
+            <a:off x="566928" y="2926080"/>
             <a:ext cx="365760" cy="228600"/>
           </a:xfrm>
           <a:prstGeom prst="rect">
@@ -14613,8 +14612,8 @@
         </p:nvSpPr>
         <p:spPr>
           <a:xfrm>
-            <a:off x="960120" y="3118104"/>
-            <a:ext cx="3566160" cy="256032"/>
+            <a:off x="960120" y="2907792"/>
+            <a:ext cx="3200400" cy="256032"/>
           </a:xfrm>
           <a:prstGeom prst="rect">
             <a:avLst/>
@@ -14643,7 +14642,7 @@
               <a:buNone/>
             </a:pPr>
             <a:r>
-              <a:rPr lang="en" sz="1150" b="1" i="0">
+              <a:rPr lang="en" sz="1100" b="1" i="0">
                 <a:solidFill>
                   <a:srgbClr val="F7E4B0"/>
                 </a:solidFill>
@@ -14665,8 +14664,8 @@
         </p:nvSpPr>
         <p:spPr>
           <a:xfrm>
-            <a:off x="4663440" y="3136392"/>
-            <a:ext cx="1828800" cy="411480"/>
+            <a:off x="4206240" y="2926080"/>
+            <a:ext cx="1737360" cy="411480"/>
           </a:xfrm>
           <a:prstGeom prst="rect">
             <a:avLst/>
@@ -14695,7 +14694,7 @@
               <a:buNone/>
             </a:pPr>
             <a:r>
-              <a:rPr lang="en" sz="1000" b="0" i="0">
+              <a:rPr lang="en" sz="950" b="0" i="0">
                 <a:solidFill>
                   <a:srgbClr val="C9B994"/>
                 </a:solidFill>
@@ -14717,7 +14716,7 @@
         </p:nvSpPr>
         <p:spPr>
           <a:xfrm>
-            <a:off x="566928" y="3758184"/>
+            <a:off x="566928" y="3456432"/>
             <a:ext cx="365760" cy="228600"/>
           </a:xfrm>
           <a:prstGeom prst="rect">
@@ -14769,8 +14768,8 @@
         </p:nvSpPr>
         <p:spPr>
           <a:xfrm>
-            <a:off x="960120" y="3739896"/>
-            <a:ext cx="3566160" cy="256032"/>
+            <a:off x="960120" y="3438144"/>
+            <a:ext cx="3200400" cy="256032"/>
           </a:xfrm>
           <a:prstGeom prst="rect">
             <a:avLst/>
@@ -14799,7 +14798,7 @@
               <a:buNone/>
             </a:pPr>
             <a:r>
-              <a:rPr lang="en" sz="1150" b="1" i="0">
+              <a:rPr lang="en" sz="1100" b="1" i="0">
                 <a:solidFill>
                   <a:srgbClr val="F7E4B0"/>
                 </a:solidFill>
@@ -14821,8 +14820,8 @@
         </p:nvSpPr>
         <p:spPr>
           <a:xfrm>
-            <a:off x="4663440" y="3758184"/>
-            <a:ext cx="1828800" cy="411480"/>
+            <a:off x="4206240" y="3456432"/>
+            <a:ext cx="1737360" cy="411480"/>
           </a:xfrm>
           <a:prstGeom prst="rect">
             <a:avLst/>
@@ -14851,7 +14850,7 @@
               <a:buNone/>
             </a:pPr>
             <a:r>
-              <a:rPr lang="en" sz="1000" b="0" i="0">
+              <a:rPr lang="en" sz="950" b="0" i="0">
                 <a:solidFill>
                   <a:srgbClr val="C9B994"/>
                 </a:solidFill>
@@ -14873,8 +14872,150 @@
         </p:nvSpPr>
         <p:spPr>
           <a:xfrm>
-            <a:off x="6675120" y="1874520"/>
-            <a:ext cx="1901952" cy="1554480"/>
+            <a:off x="566928" y="4041648"/>
+            <a:ext cx="5349240" cy="566928"/>
+          </a:xfrm>
+          <a:prstGeom prst="roundRect">
+            <a:avLst>
+              <a:gd name="adj" fmla="val 6000"/>
+            </a:avLst>
+          </a:prstGeom>
+          <a:solidFill>
+            <a:srgbClr val="0E0A06"/>
+          </a:solidFill>
+          <a:ln w="9525">
+            <a:solidFill>
+              <a:srgbClr val="3A2A18"/>
+            </a:solidFill>
+          </a:ln>
+          <a:effectLst>
+            <a:outerShdw blurRad="180000" dist="45000" dir="5400000" rotWithShape="0">
+              <a:srgbClr val="000000">
+                <a:alpha val="48000"/>
+              </a:srgbClr>
+            </a:outerShdw>
+          </a:effectLst>
+        </p:spPr>
+        <p:txBody>
+          <a:bodyPr/>
+          <a:lstStyle/>
+          <a:p/>
+        </p:txBody>
+      </p:sp>
+      <p:sp>
+        <p:nvSpPr>
+          <p:cNvPr id="37" name="tb37"/>
+          <p:cNvSpPr txBox="1"/>
+          <p:nvPr/>
+        </p:nvSpPr>
+        <p:spPr>
+          <a:xfrm>
+            <a:off x="795528" y="4160520"/>
+            <a:ext cx="1005840" cy="228600"/>
+          </a:xfrm>
+          <a:prstGeom prst="rect">
+            <a:avLst/>
+          </a:prstGeom>
+          <a:noFill/>
+          <a:ln>
+            <a:noFill/>
+          </a:ln>
+        </p:spPr>
+        <p:txBody>
+          <a:bodyPr anchorCtr="0" anchor="t" bIns="0" lIns="0" rIns="0" tIns="0" wrap="square" spcFirstLastPara="1">
+            <a:noAutofit/>
+          </a:bodyPr>
+          <a:lstStyle/>
+          <a:p>
+            <a:pPr indent="0" lvl="0" marL="0" rtl="0" algn="l">
+              <a:lnSpc>
+                <a:spcPct val="120000"/>
+              </a:lnSpc>
+              <a:spcBef>
+                <a:spcPts val="0"/>
+              </a:spcBef>
+              <a:spcAft>
+                <a:spcPts val="0"/>
+              </a:spcAft>
+              <a:buNone/>
+            </a:pPr>
+            <a:r>
+              <a:rPr lang="en" sz="900" b="0" i="0">
+                <a:solidFill>
+                  <a:srgbClr val="9A8A6B"/>
+                </a:solidFill>
+                <a:latin typeface="Courier New"/>
+                <a:ea typeface="Courier New"/>
+                <a:cs typeface="Courier New"/>
+                <a:sym typeface="Courier New"/>
+              </a:rPr>
+              <a:t>THE ASK</a:t>
+            </a:r>
+          </a:p>
+        </p:txBody>
+      </p:sp>
+      <p:sp>
+        <p:nvSpPr>
+          <p:cNvPr id="38" name="tb38"/>
+          <p:cNvSpPr txBox="1"/>
+          <p:nvPr/>
+        </p:nvSpPr>
+        <p:spPr>
+          <a:xfrm>
+            <a:off x="1783080" y="4169664"/>
+            <a:ext cx="4023360" cy="365760"/>
+          </a:xfrm>
+          <a:prstGeom prst="rect">
+            <a:avLst/>
+          </a:prstGeom>
+          <a:noFill/>
+          <a:ln>
+            <a:noFill/>
+          </a:ln>
+        </p:spPr>
+        <p:txBody>
+          <a:bodyPr anchorCtr="0" anchor="t" bIns="0" lIns="0" rIns="0" tIns="0" wrap="square" spcFirstLastPara="1">
+            <a:noAutofit/>
+          </a:bodyPr>
+          <a:lstStyle/>
+          <a:p>
+            <a:pPr indent="0" lvl="0" marL="0" rtl="0" algn="l">
+              <a:lnSpc>
+                <a:spcPct val="112000"/>
+              </a:lnSpc>
+              <a:spcBef>
+                <a:spcPts val="0"/>
+              </a:spcBef>
+              <a:spcAft>
+                <a:spcPts val="0"/>
+              </a:spcAft>
+              <a:buNone/>
+            </a:pPr>
+            <a:r>
+              <a:rPr lang="en" sz="1000" b="0" i="0">
+                <a:solidFill>
+                  <a:srgbClr val="E8834A"/>
+                </a:solidFill>
+                <a:latin typeface="Georgia"/>
+                <a:ea typeface="Georgia"/>
+                <a:cs typeface="Georgia"/>
+                <a:sym typeface="Georgia"/>
+              </a:rPr>
+              <a:t>Introductions in the ecosystem, and support into SCF Build.</a:t>
+            </a:r>
+          </a:p>
+        </p:txBody>
+      </p:sp>
+      <p:sp>
+        <p:nvSpPr>
+          <p:cNvPr id="39" name="panel39"/>
+          <p:cNvSpPr/>
+          <p:nvPr/>
+        </p:nvSpPr>
+        <p:spPr>
+          <a:xfrm>
+            <a:off x="6080760" y="1847088"/>
+            <a:ext cx="2496312" cy="2761488"/>
           </a:xfrm>
           <a:prstGeom prst="roundRect">
             <a:avLst>
@@ -14905,14 +15046,14 @@
       </p:sp>
       <p:sp>
         <p:nvSpPr>
-          <p:cNvPr id="37" name="tb37"/>
+          <p:cNvPr id="40" name="tb40"/>
           <p:cNvSpPr txBox="1"/>
           <p:nvPr/>
         </p:nvSpPr>
         <p:spPr>
           <a:xfrm>
-            <a:off x="6903720" y="2057400"/>
-            <a:ext cx="1463040" cy="1234440"/>
+            <a:off x="6291072" y="2011680"/>
+            <a:ext cx="2103120" cy="256032"/>
           </a:xfrm>
           <a:prstGeom prst="rect">
             <a:avLst/>
@@ -14936,12 +15077,116 @@
                 <a:spcPts val="0"/>
               </a:spcBef>
               <a:spcAft>
-                <a:spcPts val="600"/>
+                <a:spcPts val="0"/>
+              </a:spcAft>
+              <a:buNone/>
+            </a:pPr>
+            <a:r>
+              <a:rPr lang="en" sz="1250" b="1" i="0">
+                <a:solidFill>
+                  <a:srgbClr val="F7E4B0"/>
+                </a:solidFill>
+                <a:latin typeface="Georgia"/>
+                <a:ea typeface="Georgia"/>
+                <a:cs typeface="Georgia"/>
+                <a:sym typeface="Georgia"/>
+              </a:rPr>
+              <a:t>Furkan Yeşildağ</a:t>
+            </a:r>
+          </a:p>
+        </p:txBody>
+      </p:sp>
+      <p:sp>
+        <p:nvSpPr>
+          <p:cNvPr id="41" name="tb41"/>
+          <p:cNvSpPr txBox="1"/>
+          <p:nvPr/>
+        </p:nvSpPr>
+        <p:spPr>
+          <a:xfrm>
+            <a:off x="6291072" y="2304288"/>
+            <a:ext cx="2103120" cy="548640"/>
+          </a:xfrm>
+          <a:prstGeom prst="rect">
+            <a:avLst/>
+          </a:prstGeom>
+          <a:noFill/>
+          <a:ln>
+            <a:noFill/>
+          </a:ln>
+        </p:spPr>
+        <p:txBody>
+          <a:bodyPr anchorCtr="0" anchor="t" bIns="0" lIns="0" rIns="0" tIns="0" wrap="square" spcFirstLastPara="1">
+            <a:noAutofit/>
+          </a:bodyPr>
+          <a:lstStyle/>
+          <a:p>
+            <a:pPr indent="0" lvl="0" marL="0" rtl="0" algn="l">
+              <a:lnSpc>
+                <a:spcPct val="112000"/>
+              </a:lnSpc>
+              <a:spcBef>
+                <a:spcPts val="0"/>
+              </a:spcBef>
+              <a:spcAft>
+                <a:spcPts val="0"/>
               </a:spcAft>
               <a:buNone/>
             </a:pPr>
             <a:r>
               <a:rPr lang="en" sz="900" b="0" i="0">
+                <a:solidFill>
+                  <a:srgbClr val="C9B994"/>
+                </a:solidFill>
+                <a:latin typeface="Georgia"/>
+                <a:ea typeface="Georgia"/>
+                <a:cs typeface="Georgia"/>
+                <a:sym typeface="Georgia"/>
+              </a:rPr>
+              <a:t>Solo founder. Built the contract, the product and the agent side in three months, on mainnet since July.</a:t>
+            </a:r>
+          </a:p>
+        </p:txBody>
+      </p:sp>
+      <p:sp>
+        <p:nvSpPr>
+          <p:cNvPr id="42" name="tb42"/>
+          <p:cNvSpPr txBox="1"/>
+          <p:nvPr/>
+        </p:nvSpPr>
+        <p:spPr>
+          <a:xfrm>
+            <a:off x="6291072" y="3017520"/>
+            <a:ext cx="2103120" cy="182880"/>
+          </a:xfrm>
+          <a:prstGeom prst="rect">
+            <a:avLst/>
+          </a:prstGeom>
+          <a:noFill/>
+          <a:ln>
+            <a:noFill/>
+          </a:ln>
+        </p:spPr>
+        <p:txBody>
+          <a:bodyPr anchorCtr="0" anchor="t" bIns="0" lIns="0" rIns="0" tIns="0" wrap="square" spcFirstLastPara="1">
+            <a:noAutofit/>
+          </a:bodyPr>
+          <a:lstStyle/>
+          <a:p>
+            <a:pPr indent="0" lvl="0" marL="0" rtl="0" algn="l">
+              <a:lnSpc>
+                <a:spcPct val="120000"/>
+              </a:lnSpc>
+              <a:spcBef>
+                <a:spcPts val="0"/>
+              </a:spcBef>
+              <a:spcAft>
+                <a:spcPts val="0"/>
+              </a:spcAft>
+              <a:buNone/>
+            </a:pPr>
+            <a:r>
+              <a:rPr lang="en" sz="800" b="0" i="0">
                 <a:solidFill>
                   <a:srgbClr val="9A8A6B"/>
                 </a:solidFill>
@@ -14950,73 +15195,21 @@
                 <a:cs typeface="Courier New"/>
                 <a:sym typeface="Courier New"/>
               </a:rPr>
-              <a:t>THE ASK</a:t>
+              <a:t>EVERYTHING IS OPEN</a:t>
             </a:r>
           </a:p>
-          <a:p>
-            <a:pPr indent="0" lvl="0" marL="0" rtl="0" algn="l">
-              <a:lnSpc>
-                <a:spcPct val="115000"/>
-              </a:lnSpc>
-              <a:spcBef>
-                <a:spcPts val="0"/>
-              </a:spcBef>
-              <a:spcAft>
-                <a:spcPts val="500"/>
-              </a:spcAft>
-              <a:buNone/>
-            </a:pPr>
-            <a:r>
-              <a:rPr lang="en" sz="1050" b="0" i="0">
-                <a:solidFill>
-                  <a:srgbClr val="E8834A"/>
-                </a:solidFill>
-                <a:latin typeface="Georgia"/>
-                <a:ea typeface="Georgia"/>
-                <a:cs typeface="Georgia"/>
-                <a:sym typeface="Georgia"/>
-              </a:rPr>
-              <a:t>Introductions in the ecosystem</a:t>
-            </a:r>
-          </a:p>
-          <a:p>
-            <a:pPr indent="0" lvl="0" marL="0" rtl="0" algn="l">
-              <a:lnSpc>
-                <a:spcPct val="115000"/>
-              </a:lnSpc>
-              <a:spcBef>
-                <a:spcPts val="0"/>
-              </a:spcBef>
-              <a:spcAft>
-                <a:spcPts val="0"/>
-              </a:spcAft>
-              <a:buNone/>
-            </a:pPr>
-            <a:r>
-              <a:rPr lang="en" sz="1050" b="0" i="0">
-                <a:solidFill>
-                  <a:srgbClr val="E8834A"/>
-                </a:solidFill>
-                <a:latin typeface="Georgia"/>
-                <a:ea typeface="Georgia"/>
-                <a:cs typeface="Georgia"/>
-                <a:sym typeface="Georgia"/>
-              </a:rPr>
-              <a:t>Support into SCF Build</a:t>
-            </a:r>
-          </a:p>
-        </p:txBody>
-      </p:sp>
-      <p:sp>
-        <p:nvSpPr>
-          <p:cNvPr id="38" name="tb38"/>
+        </p:txBody>
+      </p:sp>
+      <p:sp>
+        <p:nvSpPr>
+          <p:cNvPr id="43" name="tb43"/>
           <p:cNvSpPr txBox="1"/>
           <p:nvPr/>
         </p:nvSpPr>
         <p:spPr>
           <a:xfrm>
-            <a:off x="566928" y="4206240"/>
-            <a:ext cx="8010144" cy="365760"/>
+            <a:off x="6291072" y="3246120"/>
+            <a:ext cx="2148840" cy="1280160"/>
           </a:xfrm>
           <a:prstGeom prst="rect">
             <a:avLst/>
@@ -15034,72 +15227,20 @@
           <a:p>
             <a:pPr indent="0" lvl="0" marL="0" rtl="0" algn="l">
               <a:lnSpc>
-                <a:spcPct val="112000"/>
-              </a:lnSpc>
-              <a:spcBef>
-                <a:spcPts val="0"/>
-              </a:spcBef>
-              <a:spcAft>
-                <a:spcPts val="0"/>
+                <a:spcPct val="120000"/>
+              </a:lnSpc>
+              <a:spcBef>
+                <a:spcPts val="0"/>
+              </a:spcBef>
+              <a:spcAft>
+                <a:spcPts val="400"/>
               </a:spcAft>
               <a:buNone/>
             </a:pPr>
             <a:r>
-              <a:rPr lang="en" sz="950" b="0" i="0">
-                <a:solidFill>
-                  <a:srgbClr val="9A8A6B"/>
-                </a:solidFill>
-                <a:latin typeface="Georgia"/>
-                <a:ea typeface="Georgia"/>
-                <a:cs typeface="Georgia"/>
-                <a:sym typeface="Georgia"/>
-              </a:rPr>
-              <a:t>Scope and tranches: docs/ARCHITECTURE.md, sections 5 and 6. Cogladius stays on mainnet either way.</a:t>
-            </a:r>
-          </a:p>
-        </p:txBody>
-      </p:sp>
-      <p:sp>
-        <p:nvSpPr>
-          <p:cNvPr id="40" name="tb40"/>
-          <p:cNvSpPr txBox="1"/>
-          <p:nvPr/>
-        </p:nvSpPr>
-        <p:spPr>
-          <a:xfrm>
-            <a:off x="804672" y="4690872"/>
-            <a:ext cx="2743200" cy="182880"/>
-          </a:xfrm>
-          <a:prstGeom prst="rect">
-            <a:avLst/>
-          </a:prstGeom>
-          <a:noFill/>
-          <a:ln>
-            <a:noFill/>
-          </a:ln>
-        </p:spPr>
-        <p:txBody>
-          <a:bodyPr anchorCtr="0" anchor="t" bIns="0" lIns="0" rIns="0" tIns="0" wrap="square" spcFirstLastPara="1">
-            <a:noAutofit/>
-          </a:bodyPr>
-          <a:lstStyle/>
-          <a:p>
-            <a:pPr indent="0" lvl="0" marL="0" rtl="0" algn="l">
-              <a:lnSpc>
-                <a:spcPct val="120000"/>
-              </a:lnSpc>
-              <a:spcBef>
-                <a:spcPts val="0"/>
-              </a:spcBef>
-              <a:spcAft>
-                <a:spcPts val="0"/>
-              </a:spcAft>
-              <a:buNone/>
-            </a:pPr>
-            <a:r>
-              <a:rPr lang="en" sz="750" b="0" i="0">
-                <a:solidFill>
-                  <a:srgbClr val="6B5C45"/>
+              <a:rPr lang="en" sz="1000" b="0" i="0">
+                <a:solidFill>
+                  <a:srgbClr val="E8834A"/>
                 </a:solidFill>
                 <a:latin typeface="Courier New"/>
                 <a:ea typeface="Courier New"/>
@@ -15109,202 +15250,73 @@
               <a:t>cogladius.xyz</a:t>
             </a:r>
           </a:p>
-        </p:txBody>
-      </p:sp>
-      <p:sp>
-        <p:nvSpPr>
-          <p:cNvPr id="41" name="tb41"/>
-          <p:cNvSpPr txBox="1"/>
-          <p:nvPr/>
-        </p:nvSpPr>
-        <p:spPr>
-          <a:xfrm>
-            <a:off x="5833872" y="4690872"/>
-            <a:ext cx="2743200" cy="182880"/>
-          </a:xfrm>
-          <a:prstGeom prst="rect">
-            <a:avLst/>
-          </a:prstGeom>
-          <a:noFill/>
-          <a:ln>
-            <a:noFill/>
-          </a:ln>
-        </p:spPr>
-        <p:txBody>
-          <a:bodyPr anchorCtr="0" anchor="t" bIns="0" lIns="0" rIns="0" tIns="0" wrap="square" spcFirstLastPara="1">
-            <a:noAutofit/>
-          </a:bodyPr>
-          <a:lstStyle/>
-          <a:p>
-            <a:pPr indent="0" lvl="0" marL="0" rtl="0" algn="r">
-              <a:lnSpc>
-                <a:spcPct val="120000"/>
-              </a:lnSpc>
-              <a:spcBef>
-                <a:spcPts val="0"/>
-              </a:spcBef>
-              <a:spcAft>
-                <a:spcPts val="0"/>
+          <a:p>
+            <a:pPr indent="0" lvl="0" marL="0" rtl="0" algn="l">
+              <a:lnSpc>
+                <a:spcPct val="112000"/>
+              </a:lnSpc>
+              <a:spcBef>
+                <a:spcPts val="0"/>
+              </a:spcBef>
+              <a:spcAft>
+                <a:spcPts val="400"/>
               </a:spcAft>
               <a:buNone/>
             </a:pPr>
             <a:r>
-              <a:rPr lang="en" sz="750" b="0" i="0">
-                <a:solidFill>
-                  <a:srgbClr val="6B5C45"/>
+              <a:rPr lang="en" sz="900" b="0" i="0">
+                <a:solidFill>
+                  <a:srgbClr val="E8834A"/>
                 </a:solidFill>
                 <a:latin typeface="Courier New"/>
                 <a:ea typeface="Courier New"/>
                 <a:cs typeface="Courier New"/>
                 <a:sym typeface="Courier New"/>
               </a:rPr>
-              <a:t>7 / 8</a:t>
+              <a:t>cogladius.xyz/join</a:t>
             </a:r>
           </a:p>
-        </p:txBody>
-      </p:sp>
-      <p:pic>
-        <p:nvPicPr>
-          <p:cNvPr id="39" name="pic39"/>
-          <p:cNvPicPr preferRelativeResize="0"/>
-          <p:nvPr/>
-        </p:nvPicPr>
-        <p:blipFill>
-          <a:blip r:embed="rId2"/>
-          <a:stretch>
-            <a:fillRect/>
-          </a:stretch>
-        </p:blipFill>
-        <p:spPr>
-          <a:xfrm>
-            <a:off x="566928" y="4645152"/>
-            <a:ext cx="173736" cy="173736"/>
-          </a:xfrm>
-          <a:prstGeom prst="rect">
-            <a:avLst/>
-          </a:prstGeom>
-          <a:ln>
-            <a:noFill/>
-          </a:ln>
-        </p:spPr>
-      </p:pic>
-    </p:spTree>
-  </p:cSld>
-  <p:clrMapOvr>
-    <a:masterClrMapping/>
-  </p:clrMapOvr>
-</p:sld>
-</file>
-
-<file path=ppt/slides/slide8.xml><?xml version="1.0" encoding="utf-8"?>
-<p:sld xmlns:a="http://schemas.openxmlformats.org/drawingml/2006/main" xmlns:r="http://schemas.openxmlformats.org/officeDocument/2006/relationships" xmlns:p="http://schemas.openxmlformats.org/presentationml/2006/main">
-  <p:cSld>
-    <p:spTree>
-      <p:nvGrpSpPr>
-        <p:cNvPr id="1" name="Shape 1"/>
-        <p:cNvGrpSpPr/>
-        <p:nvPr/>
-      </p:nvGrpSpPr>
-      <p:grpSpPr>
-        <a:xfrm>
-          <a:off x="0" y="0"/>
-          <a:ext cx="0" cy="0"/>
-          <a:chOff x="0" y="0"/>
-          <a:chExt cx="0" cy="0"/>
-        </a:xfrm>
-      </p:grpSpPr>
-      <p:sp>
-        <p:nvSpPr>
-          <p:cNvPr id="9" name="bg"/>
-          <p:cNvSpPr/>
-          <p:nvPr/>
-        </p:nvSpPr>
-        <p:spPr>
-          <a:xfrm>
-            <a:off x="0" y="0"/>
-            <a:ext cx="9144000" cy="5143500"/>
-          </a:xfrm>
-          <a:prstGeom prst="rect">
-            <a:avLst/>
-          </a:prstGeom>
-          <a:gradFill>
-            <a:gsLst>
-              <a:gs pos="0">
-                <a:srgbClr val="1C0F08"/>
-              </a:gs>
-              <a:gs pos="55000">
-                <a:srgbClr val="0B0605"/>
-              </a:gs>
-              <a:gs pos="100000">
-                <a:srgbClr val="070503"/>
-              </a:gs>
-            </a:gsLst>
-            <a:path path="circle">
-              <a:fillToRect b="50%" l="50%" r="50%" t="50%"/>
-            </a:path>
-            <a:tileRect/>
-          </a:gradFill>
-          <a:ln>
-            <a:noFill/>
-          </a:ln>
-        </p:spPr>
-        <p:txBody>
-          <a:bodyPr/>
-          <a:lstStyle/>
-          <a:p/>
-        </p:txBody>
-      </p:sp>
-      <p:sp>
-        <p:nvSpPr>
-          <p:cNvPr id="21" name="tb21"/>
-          <p:cNvSpPr txBox="1"/>
-          <p:nvPr/>
-        </p:nvSpPr>
-        <p:spPr>
-          <a:xfrm>
-            <a:off x="566928" y="310896"/>
-            <a:ext cx="7315200" cy="228600"/>
-          </a:xfrm>
-          <a:prstGeom prst="rect">
-            <a:avLst/>
-          </a:prstGeom>
-          <a:noFill/>
-          <a:ln>
-            <a:noFill/>
-          </a:ln>
-        </p:spPr>
-        <p:txBody>
-          <a:bodyPr anchorCtr="0" anchor="t" bIns="0" lIns="0" rIns="0" tIns="0" wrap="square" spcFirstLastPara="1">
-            <a:noAutofit/>
-          </a:bodyPr>
-          <a:lstStyle/>
           <a:p>
             <a:pPr indent="0" lvl="0" marL="0" rtl="0" algn="l">
               <a:lnSpc>
-                <a:spcPct val="120000"/>
-              </a:lnSpc>
-              <a:spcBef>
-                <a:spcPts val="0"/>
-              </a:spcBef>
-              <a:spcAft>
-                <a:spcPts val="0"/>
+                <a:spcPct val="112000"/>
+              </a:lnSpc>
+              <a:spcBef>
+                <a:spcPts val="0"/>
+              </a:spcBef>
+              <a:spcAft>
+                <a:spcPts val="400"/>
               </a:spcAft>
               <a:buNone/>
             </a:pPr>
             <a:r>
-              <a:rPr lang="en" sz="900" b="1" i="0">
-                <a:solidFill>
-                  <a:srgbClr val="E8834A"/>
+              <a:rPr lang="en" sz="800" b="0" i="0">
+                <a:solidFill>
+                  <a:srgbClr val="C9B994"/>
                 </a:solidFill>
                 <a:latin typeface="Courier New"/>
                 <a:ea typeface="Courier New"/>
                 <a:cs typeface="Courier New"/>
                 <a:sym typeface="Courier New"/>
               </a:rPr>
-              <a:t>08</a:t>
+              <a:t>github.com/furkanyesildag/cogladius</a:t>
             </a:r>
+          </a:p>
+          <a:p>
+            <a:pPr indent="0" lvl="0" marL="0" rtl="0" algn="l">
+              <a:lnSpc>
+                <a:spcPct val="112000"/>
+              </a:lnSpc>
+              <a:spcBef>
+                <a:spcPts val="0"/>
+              </a:spcBef>
+              <a:spcAft>
+                <a:spcPts val="0"/>
+              </a:spcAft>
+              <a:buNone/>
+            </a:pPr>
             <a:r>
-              <a:rPr lang="en" sz="900" b="0" i="0">
+              <a:rPr lang="en" sz="800" b="0" i="0">
                 <a:solidFill>
                   <a:srgbClr val="9A8A6B"/>
                 </a:solidFill>
@@ -15313,21 +15325,21 @@
                 <a:cs typeface="Courier New"/>
                 <a:sym typeface="Courier New"/>
               </a:rPr>
-              <a:t>   THE TEAM</a:t>
+              <a:t>MIT · escrow CAC5EDF7…K75PL</a:t>
             </a:r>
           </a:p>
         </p:txBody>
       </p:sp>
       <p:sp>
         <p:nvSpPr>
-          <p:cNvPr id="22" name="tb22"/>
+          <p:cNvPr id="45" name="tb45"/>
           <p:cNvSpPr txBox="1"/>
           <p:nvPr/>
         </p:nvSpPr>
         <p:spPr>
           <a:xfrm>
-            <a:off x="566928" y="566928"/>
-            <a:ext cx="7863840" cy="731520"/>
+            <a:off x="804672" y="4690872"/>
+            <a:ext cx="2743200" cy="182880"/>
           </a:xfrm>
           <a:prstGeom prst="rect">
             <a:avLst/>
@@ -15345,7 +15357,7 @@
           <a:p>
             <a:pPr indent="0" lvl="0" marL="0" rtl="0" algn="l">
               <a:lnSpc>
-                <a:spcPct val="92000"/>
+                <a:spcPct val="120000"/>
               </a:lnSpc>
               <a:spcBef>
                 <a:spcPts val="0"/>
@@ -15356,426 +15368,9 @@
               <a:buNone/>
             </a:pPr>
             <a:r>
-              <a:rPr lang="en" sz="3200" b="1" i="0">
-                <a:solidFill>
-                  <a:srgbClr val="F7E4B0"/>
-                </a:solidFill>
-                <a:latin typeface="Georgia"/>
-                <a:ea typeface="Georgia"/>
-                <a:cs typeface="Georgia"/>
-                <a:sym typeface="Georgia"/>
-              </a:rPr>
-              <a:t>The Team</a:t>
-            </a:r>
-          </a:p>
-        </p:txBody>
-      </p:sp>
-      <p:sp>
-        <p:nvSpPr>
-          <p:cNvPr id="23" name="tb23"/>
-          <p:cNvSpPr txBox="1"/>
-          <p:nvPr/>
-        </p:nvSpPr>
-        <p:spPr>
-          <a:xfrm>
-            <a:off x="566928" y="1298448"/>
-            <a:ext cx="7589520" cy="566928"/>
-          </a:xfrm>
-          <a:prstGeom prst="rect">
-            <a:avLst/>
-          </a:prstGeom>
-          <a:noFill/>
-          <a:ln>
-            <a:noFill/>
-          </a:ln>
-        </p:spPr>
-        <p:txBody>
-          <a:bodyPr anchorCtr="0" anchor="t" bIns="0" lIns="0" rIns="0" tIns="0" wrap="square" spcFirstLastPara="1">
-            <a:noAutofit/>
-          </a:bodyPr>
-          <a:lstStyle/>
-          <a:p>
-            <a:pPr indent="0" lvl="0" marL="0" rtl="0" algn="l">
-              <a:lnSpc>
-                <a:spcPct val="125000"/>
-              </a:lnSpc>
-              <a:spcBef>
-                <a:spcPts val="0"/>
-              </a:spcBef>
-              <a:spcAft>
-                <a:spcPts val="0"/>
-              </a:spcAft>
-              <a:buNone/>
-            </a:pPr>
-            <a:r>
-              <a:rPr lang="en" sz="1200" b="0" i="0">
-                <a:solidFill>
-                  <a:srgbClr val="D8C9A6"/>
-                </a:solidFill>
-                <a:latin typeface="Georgia"/>
-                <a:ea typeface="Georgia"/>
-                <a:cs typeface="Georgia"/>
-                <a:sym typeface="Georgia"/>
-              </a:rPr>
-              <a:t>One person. Built in three months and shipped to Stellar mainnet in July.</a:t>
-            </a:r>
-          </a:p>
-        </p:txBody>
-      </p:sp>
-      <p:sp>
-        <p:nvSpPr>
-          <p:cNvPr id="24" name="tb24"/>
-          <p:cNvSpPr txBox="1"/>
-          <p:nvPr/>
-        </p:nvSpPr>
-        <p:spPr>
-          <a:xfrm>
-            <a:off x="566928" y="1920240"/>
-            <a:ext cx="4206240" cy="320040"/>
-          </a:xfrm>
-          <a:prstGeom prst="rect">
-            <a:avLst/>
-          </a:prstGeom>
-          <a:noFill/>
-          <a:ln>
-            <a:noFill/>
-          </a:ln>
-        </p:spPr>
-        <p:txBody>
-          <a:bodyPr anchorCtr="0" anchor="t" bIns="0" lIns="0" rIns="0" tIns="0" wrap="square" spcFirstLastPara="1">
-            <a:noAutofit/>
-          </a:bodyPr>
-          <a:lstStyle/>
-          <a:p>
-            <a:pPr indent="0" lvl="0" marL="0" rtl="0" algn="l">
-              <a:lnSpc>
-                <a:spcPct val="120000"/>
-              </a:lnSpc>
-              <a:spcBef>
-                <a:spcPts val="0"/>
-              </a:spcBef>
-              <a:spcAft>
-                <a:spcPts val="0"/>
-              </a:spcAft>
-              <a:buNone/>
-            </a:pPr>
-            <a:r>
-              <a:rPr lang="en" sz="1800" b="1" i="0">
-                <a:solidFill>
-                  <a:srgbClr val="F7E4B0"/>
-                </a:solidFill>
-                <a:latin typeface="Georgia"/>
-                <a:ea typeface="Georgia"/>
-                <a:cs typeface="Georgia"/>
-                <a:sym typeface="Georgia"/>
-              </a:rPr>
-              <a:t>Furkan Yeşildağ</a:t>
-            </a:r>
-          </a:p>
-        </p:txBody>
-      </p:sp>
-      <p:sp>
-        <p:nvSpPr>
-          <p:cNvPr id="25" name="tb25"/>
-          <p:cNvSpPr txBox="1"/>
-          <p:nvPr/>
-        </p:nvSpPr>
-        <p:spPr>
-          <a:xfrm>
-            <a:off x="566928" y="2331720"/>
-            <a:ext cx="4206240" cy="228600"/>
-          </a:xfrm>
-          <a:prstGeom prst="rect">
-            <a:avLst/>
-          </a:prstGeom>
-          <a:noFill/>
-          <a:ln>
-            <a:noFill/>
-          </a:ln>
-        </p:spPr>
-        <p:txBody>
-          <a:bodyPr anchorCtr="0" anchor="t" bIns="0" lIns="0" rIns="0" tIns="0" wrap="square" spcFirstLastPara="1">
-            <a:noAutofit/>
-          </a:bodyPr>
-          <a:lstStyle/>
-          <a:p>
-            <a:pPr indent="0" lvl="0" marL="0" rtl="0" algn="l">
-              <a:lnSpc>
-                <a:spcPct val="120000"/>
-              </a:lnSpc>
-              <a:spcBef>
-                <a:spcPts val="0"/>
-              </a:spcBef>
-              <a:spcAft>
-                <a:spcPts val="0"/>
-              </a:spcAft>
-              <a:buNone/>
-            </a:pPr>
-            <a:r>
-              <a:rPr lang="en" sz="1100" b="0" i="0">
-                <a:solidFill>
-                  <a:srgbClr val="C9B994"/>
-                </a:solidFill>
-                <a:latin typeface="Georgia"/>
-                <a:ea typeface="Georgia"/>
-                <a:cs typeface="Georgia"/>
-                <a:sym typeface="Georgia"/>
-              </a:rPr>
-              <a:t>Solo founder · contract, product, agents, infrastructure</a:t>
-            </a:r>
-          </a:p>
-        </p:txBody>
-      </p:sp>
-      <p:sp>
-        <p:nvSpPr>
-          <p:cNvPr id="26" name="tb26"/>
-          <p:cNvSpPr txBox="1"/>
-          <p:nvPr/>
-        </p:nvSpPr>
-        <p:spPr>
-          <a:xfrm>
-            <a:off x="566928" y="2743200"/>
-            <a:ext cx="4480560" cy="1188720"/>
-          </a:xfrm>
-          <a:prstGeom prst="rect">
-            <a:avLst/>
-          </a:prstGeom>
-          <a:noFill/>
-          <a:ln>
-            <a:noFill/>
-          </a:ln>
-        </p:spPr>
-        <p:txBody>
-          <a:bodyPr anchorCtr="0" anchor="t" bIns="0" lIns="0" rIns="0" tIns="0" wrap="square" spcFirstLastPara="1">
-            <a:noAutofit/>
-          </a:bodyPr>
-          <a:lstStyle/>
-          <a:p>
-            <a:pPr indent="-330200" lvl="0" marL="457200" rtl="0" algn="l">
-              <a:lnSpc>
-                <a:spcPct val="118000"/>
-              </a:lnSpc>
-              <a:spcBef>
-                <a:spcPts val="0"/>
-              </a:spcBef>
-              <a:spcAft>
-                <a:spcPts val="520"/>
-              </a:spcAft>
-              <a:buClr>
-                <a:srgbClr val="E8834A"/>
-              </a:buClr>
-              <a:buSzPts val="1100"/>
-              <a:buFont typeface="Georgia"/>
-              <a:buChar char="•"/>
-            </a:pPr>
-            <a:r>
-              <a:rPr lang="en" sz="1050" b="0" i="0">
-                <a:solidFill>
-                  <a:srgbClr val="F7E4B0"/>
-                </a:solidFill>
-                <a:latin typeface="Georgia"/>
-                <a:ea typeface="Georgia"/>
-                <a:cs typeface="Georgia"/>
-                <a:sym typeface="Georgia"/>
-              </a:rPr>
-              <a:t>Wrote the Soroban escrow in Rust, with 16 tests including a forged-verdict rejection.</a:t>
-            </a:r>
-          </a:p>
-          <a:p>
-            <a:pPr indent="-330200" lvl="0" marL="457200" rtl="0" algn="l">
-              <a:lnSpc>
-                <a:spcPct val="118000"/>
-              </a:lnSpc>
-              <a:spcBef>
-                <a:spcPts val="0"/>
-              </a:spcBef>
-              <a:spcAft>
-                <a:spcPts val="520"/>
-              </a:spcAft>
-              <a:buClr>
-                <a:srgbClr val="E8834A"/>
-              </a:buClr>
-              <a:buSzPts val="1100"/>
-              <a:buFont typeface="Georgia"/>
-              <a:buChar char="•"/>
-            </a:pPr>
-            <a:r>
-              <a:rPr lang="en" sz="1050" b="0" i="0">
-                <a:solidFill>
-                  <a:srgbClr val="F7E4B0"/>
-                </a:solidFill>
-                <a:latin typeface="Georgia"/>
-                <a:ea typeface="Georgia"/>
-                <a:cs typeface="Georgia"/>
-                <a:sym typeface="Georgia"/>
-              </a:rPr>
-              <a:t>Built the product, the agent SDK and the MCP server, and ran the mainnet migration.</a:t>
-            </a:r>
-          </a:p>
-          <a:p>
-            <a:pPr indent="-330200" lvl="0" marL="457200" rtl="0" algn="l">
-              <a:lnSpc>
-                <a:spcPct val="118000"/>
-              </a:lnSpc>
-              <a:spcBef>
-                <a:spcPts val="0"/>
-              </a:spcBef>
-              <a:spcAft>
-                <a:spcPts val="520"/>
-              </a:spcAft>
-              <a:buClr>
-                <a:srgbClr val="E8834A"/>
-              </a:buClr>
-              <a:buSzPts val="1100"/>
-              <a:buFont typeface="Georgia"/>
-              <a:buChar char="•"/>
-            </a:pPr>
-            <a:r>
-              <a:rPr lang="en" sz="1050" b="0" i="0">
-                <a:solidFill>
-                  <a:srgbClr val="F7E4B0"/>
-                </a:solidFill>
-                <a:latin typeface="Georgia"/>
-                <a:ea typeface="Georgia"/>
-                <a:cs typeface="Georgia"/>
-                <a:sym typeface="Georgia"/>
-              </a:rPr>
-              <a:t>Listed in Stellar's skills directory, so agents can onboard themselves.</a:t>
-            </a:r>
-          </a:p>
-        </p:txBody>
-      </p:sp>
-      <p:sp>
-        <p:nvSpPr>
-          <p:cNvPr id="27" name="panel27"/>
-          <p:cNvSpPr/>
-          <p:nvPr/>
-        </p:nvSpPr>
-        <p:spPr>
-          <a:xfrm>
-            <a:off x="5303520" y="1874520"/>
-            <a:ext cx="1554480" cy="1645920"/>
-          </a:xfrm>
-          <a:prstGeom prst="roundRect">
-            <a:avLst>
-              <a:gd name="adj" fmla="val 6000"/>
-            </a:avLst>
-          </a:prstGeom>
-          <a:solidFill>
-            <a:srgbClr val="0B0705"/>
-          </a:solidFill>
-          <a:ln w="9525">
-            <a:solidFill>
-              <a:srgbClr val="3A2A18"/>
-            </a:solidFill>
-          </a:ln>
-          <a:effectLst>
-            <a:outerShdw blurRad="180000" dist="45000" dir="5400000" rotWithShape="0">
-              <a:srgbClr val="000000">
-                <a:alpha val="48000"/>
-              </a:srgbClr>
-            </a:outerShdw>
-          </a:effectLst>
-        </p:spPr>
-        <p:txBody>
-          <a:bodyPr/>
-          <a:lstStyle/>
-          <a:p/>
-        </p:txBody>
-      </p:sp>
-      <p:sp>
-        <p:nvSpPr>
-          <p:cNvPr id="28" name="tb28"/>
-          <p:cNvSpPr txBox="1"/>
-          <p:nvPr/>
-        </p:nvSpPr>
-        <p:spPr>
-          <a:xfrm>
-            <a:off x="5303520" y="2560320"/>
-            <a:ext cx="1554480" cy="228600"/>
-          </a:xfrm>
-          <a:prstGeom prst="rect">
-            <a:avLst/>
-          </a:prstGeom>
-          <a:noFill/>
-          <a:ln>
-            <a:noFill/>
-          </a:ln>
-        </p:spPr>
-        <p:txBody>
-          <a:bodyPr anchorCtr="0" anchor="t" bIns="0" lIns="0" rIns="0" tIns="0" wrap="square" spcFirstLastPara="1">
-            <a:noAutofit/>
-          </a:bodyPr>
-          <a:lstStyle/>
-          <a:p>
-            <a:pPr indent="0" lvl="0" marL="0" rtl="0" algn="ctr">
-              <a:lnSpc>
-                <a:spcPct val="120000"/>
-              </a:lnSpc>
-              <a:spcBef>
-                <a:spcPts val="0"/>
-              </a:spcBef>
-              <a:spcAft>
-                <a:spcPts val="0"/>
-              </a:spcAft>
-              <a:buNone/>
-            </a:pPr>
-            <a:r>
-              <a:rPr lang="en" sz="900" b="0" i="0">
-                <a:solidFill>
-                  <a:srgbClr val="9A8A6B"/>
-                </a:solidFill>
-                <a:latin typeface="Courier New"/>
-                <a:ea typeface="Courier New"/>
-                <a:cs typeface="Courier New"/>
-                <a:sym typeface="Courier New"/>
-              </a:rPr>
-              <a:t>photo</a:t>
-            </a:r>
-          </a:p>
-        </p:txBody>
-      </p:sp>
-      <p:sp>
-        <p:nvSpPr>
-          <p:cNvPr id="29" name="tb29"/>
-          <p:cNvSpPr txBox="1"/>
-          <p:nvPr/>
-        </p:nvSpPr>
-        <p:spPr>
-          <a:xfrm>
-            <a:off x="7040880" y="1874520"/>
-            <a:ext cx="1536192" cy="1737360"/>
-          </a:xfrm>
-          <a:prstGeom prst="rect">
-            <a:avLst/>
-          </a:prstGeom>
-          <a:noFill/>
-          <a:ln>
-            <a:noFill/>
-          </a:ln>
-        </p:spPr>
-        <p:txBody>
-          <a:bodyPr anchorCtr="0" anchor="t" bIns="0" lIns="0" rIns="0" tIns="0" wrap="square" spcFirstLastPara="1">
-            <a:noAutofit/>
-          </a:bodyPr>
-          <a:lstStyle/>
-          <a:p>
-            <a:pPr indent="0" lvl="0" marL="0" rtl="0" algn="l">
-              <a:lnSpc>
-                <a:spcPct val="120000"/>
-              </a:lnSpc>
-              <a:spcBef>
-                <a:spcPts val="0"/>
-              </a:spcBef>
-              <a:spcAft>
-                <a:spcPts val="350"/>
-              </a:spcAft>
-              <a:buNone/>
-            </a:pPr>
-            <a:r>
-              <a:rPr lang="en" sz="1000" b="0" i="0">
-                <a:solidFill>
-                  <a:srgbClr val="E8834A"/>
+              <a:rPr lang="en" sz="750" b="0" i="0">
+                <a:solidFill>
+                  <a:srgbClr val="6B5C45"/>
                 </a:solidFill>
                 <a:latin typeface="Courier New"/>
                 <a:ea typeface="Courier New"/>
@@ -15785,245 +15380,63 @@
               <a:t>cogladius.xyz</a:t>
             </a:r>
           </a:p>
-          <a:p>
-            <a:pPr indent="0" lvl="0" marL="0" rtl="0" algn="l">
-              <a:lnSpc>
-                <a:spcPct val="112000"/>
-              </a:lnSpc>
-              <a:spcBef>
-                <a:spcPts val="0"/>
-              </a:spcBef>
-              <a:spcAft>
-                <a:spcPts val="350"/>
+        </p:txBody>
+      </p:sp>
+      <p:sp>
+        <p:nvSpPr>
+          <p:cNvPr id="46" name="tb46"/>
+          <p:cNvSpPr txBox="1"/>
+          <p:nvPr/>
+        </p:nvSpPr>
+        <p:spPr>
+          <a:xfrm>
+            <a:off x="5833872" y="4690872"/>
+            <a:ext cx="2743200" cy="182880"/>
+          </a:xfrm>
+          <a:prstGeom prst="rect">
+            <a:avLst/>
+          </a:prstGeom>
+          <a:noFill/>
+          <a:ln>
+            <a:noFill/>
+          </a:ln>
+        </p:spPr>
+        <p:txBody>
+          <a:bodyPr anchorCtr="0" anchor="t" bIns="0" lIns="0" rIns="0" tIns="0" wrap="square" spcFirstLastPara="1">
+            <a:noAutofit/>
+          </a:bodyPr>
+          <a:lstStyle/>
+          <a:p>
+            <a:pPr indent="0" lvl="0" marL="0" rtl="0" algn="r">
+              <a:lnSpc>
+                <a:spcPct val="120000"/>
+              </a:lnSpc>
+              <a:spcBef>
+                <a:spcPts val="0"/>
+              </a:spcBef>
+              <a:spcAft>
+                <a:spcPts val="0"/>
               </a:spcAft>
               <a:buNone/>
             </a:pPr>
             <a:r>
-              <a:rPr lang="en" sz="950" b="0" i="0">
-                <a:solidFill>
-                  <a:srgbClr val="E8834A"/>
+              <a:rPr lang="en" sz="750" b="0" i="0">
+                <a:solidFill>
+                  <a:srgbClr val="6B5C45"/>
                 </a:solidFill>
                 <a:latin typeface="Courier New"/>
                 <a:ea typeface="Courier New"/>
                 <a:cs typeface="Courier New"/>
                 <a:sym typeface="Courier New"/>
               </a:rPr>
-              <a:t>cogladius.xyz/join</a:t>
-            </a:r>
-          </a:p>
-          <a:p>
-            <a:pPr indent="0" lvl="0" marL="0" rtl="0" algn="l">
-              <a:lnSpc>
-                <a:spcPct val="112000"/>
-              </a:lnSpc>
-              <a:spcBef>
-                <a:spcPts val="0"/>
-              </a:spcBef>
-              <a:spcAft>
-                <a:spcPts val="350"/>
-              </a:spcAft>
-              <a:buNone/>
-            </a:pPr>
-            <a:r>
-              <a:rPr lang="en" sz="850" b="0" i="0">
-                <a:solidFill>
-                  <a:srgbClr val="C9B994"/>
-                </a:solidFill>
-                <a:latin typeface="Courier New"/>
-                <a:ea typeface="Courier New"/>
-                <a:cs typeface="Courier New"/>
-                <a:sym typeface="Courier New"/>
-              </a:rPr>
-              <a:t>github.com/furkanyesildag/cogladius</a:t>
-            </a:r>
-          </a:p>
-          <a:p>
-            <a:pPr indent="0" lvl="0" marL="0" rtl="0" algn="l">
-              <a:lnSpc>
-                <a:spcPct val="112000"/>
-              </a:lnSpc>
-              <a:spcBef>
-                <a:spcPts val="0"/>
-              </a:spcBef>
-              <a:spcAft>
-                <a:spcPts val="0"/>
-              </a:spcAft>
-              <a:buNone/>
-            </a:pPr>
-            <a:r>
-              <a:rPr lang="en" sz="850" b="0" i="0">
-                <a:solidFill>
-                  <a:srgbClr val="C9B994"/>
-                </a:solidFill>
-                <a:latin typeface="Courier New"/>
-                <a:ea typeface="Courier New"/>
-                <a:cs typeface="Courier New"/>
-                <a:sym typeface="Courier New"/>
-              </a:rPr>
-              <a:t>cogladius.xyz/skill.md</a:t>
-            </a:r>
-          </a:p>
-        </p:txBody>
-      </p:sp>
-      <p:sp>
-        <p:nvSpPr>
-          <p:cNvPr id="30" name="tb30"/>
-          <p:cNvSpPr txBox="1"/>
-          <p:nvPr/>
-        </p:nvSpPr>
-        <p:spPr>
-          <a:xfrm>
-            <a:off x="566928" y="4160520"/>
-            <a:ext cx="8010144" cy="228600"/>
-          </a:xfrm>
-          <a:prstGeom prst="rect">
-            <a:avLst/>
-          </a:prstGeom>
-          <a:noFill/>
-          <a:ln>
-            <a:noFill/>
-          </a:ln>
-        </p:spPr>
-        <p:txBody>
-          <a:bodyPr anchorCtr="0" anchor="t" bIns="0" lIns="0" rIns="0" tIns="0" wrap="square" spcFirstLastPara="1">
-            <a:noAutofit/>
-          </a:bodyPr>
-          <a:lstStyle/>
-          <a:p>
-            <a:pPr indent="0" lvl="0" marL="0" rtl="0" algn="l">
-              <a:lnSpc>
-                <a:spcPct val="120000"/>
-              </a:lnSpc>
-              <a:spcBef>
-                <a:spcPts val="0"/>
-              </a:spcBef>
-              <a:spcAft>
-                <a:spcPts val="0"/>
-              </a:spcAft>
-              <a:buNone/>
-            </a:pPr>
-            <a:r>
-              <a:rPr lang="en" sz="850" b="0" i="0">
-                <a:solidFill>
-                  <a:srgbClr val="9A8A6B"/>
-                </a:solidFill>
-                <a:latin typeface="Courier New"/>
-                <a:ea typeface="Courier New"/>
-                <a:cs typeface="Courier New"/>
-                <a:sym typeface="Courier New"/>
-              </a:rPr>
-              <a:t>Escrow on Stellar mainnet  CAC5EDF76M5LY43BNHT47Y5NZRHO4ZRH7SRFPNHATGNKN2DI3SNK75PL  ·  MIT</a:t>
-            </a:r>
-          </a:p>
-        </p:txBody>
-      </p:sp>
-      <p:sp>
-        <p:nvSpPr>
-          <p:cNvPr id="32" name="tb32"/>
-          <p:cNvSpPr txBox="1"/>
-          <p:nvPr/>
-        </p:nvSpPr>
-        <p:spPr>
-          <a:xfrm>
-            <a:off x="804672" y="4690872"/>
-            <a:ext cx="2743200" cy="182880"/>
-          </a:xfrm>
-          <a:prstGeom prst="rect">
-            <a:avLst/>
-          </a:prstGeom>
-          <a:noFill/>
-          <a:ln>
-            <a:noFill/>
-          </a:ln>
-        </p:spPr>
-        <p:txBody>
-          <a:bodyPr anchorCtr="0" anchor="t" bIns="0" lIns="0" rIns="0" tIns="0" wrap="square" spcFirstLastPara="1">
-            <a:noAutofit/>
-          </a:bodyPr>
-          <a:lstStyle/>
-          <a:p>
-            <a:pPr indent="0" lvl="0" marL="0" rtl="0" algn="l">
-              <a:lnSpc>
-                <a:spcPct val="120000"/>
-              </a:lnSpc>
-              <a:spcBef>
-                <a:spcPts val="0"/>
-              </a:spcBef>
-              <a:spcAft>
-                <a:spcPts val="0"/>
-              </a:spcAft>
-              <a:buNone/>
-            </a:pPr>
-            <a:r>
-              <a:rPr lang="en" sz="750" b="0" i="0">
-                <a:solidFill>
-                  <a:srgbClr val="6B5C45"/>
-                </a:solidFill>
-                <a:latin typeface="Courier New"/>
-                <a:ea typeface="Courier New"/>
-                <a:cs typeface="Courier New"/>
-                <a:sym typeface="Courier New"/>
-              </a:rPr>
-              <a:t>cogladius.xyz</a:t>
-            </a:r>
-          </a:p>
-        </p:txBody>
-      </p:sp>
-      <p:sp>
-        <p:nvSpPr>
-          <p:cNvPr id="33" name="tb33"/>
-          <p:cNvSpPr txBox="1"/>
-          <p:nvPr/>
-        </p:nvSpPr>
-        <p:spPr>
-          <a:xfrm>
-            <a:off x="5833872" y="4690872"/>
-            <a:ext cx="2743200" cy="182880"/>
-          </a:xfrm>
-          <a:prstGeom prst="rect">
-            <a:avLst/>
-          </a:prstGeom>
-          <a:noFill/>
-          <a:ln>
-            <a:noFill/>
-          </a:ln>
-        </p:spPr>
-        <p:txBody>
-          <a:bodyPr anchorCtr="0" anchor="t" bIns="0" lIns="0" rIns="0" tIns="0" wrap="square" spcFirstLastPara="1">
-            <a:noAutofit/>
-          </a:bodyPr>
-          <a:lstStyle/>
-          <a:p>
-            <a:pPr indent="0" lvl="0" marL="0" rtl="0" algn="r">
-              <a:lnSpc>
-                <a:spcPct val="120000"/>
-              </a:lnSpc>
-              <a:spcBef>
-                <a:spcPts val="0"/>
-              </a:spcBef>
-              <a:spcAft>
-                <a:spcPts val="0"/>
-              </a:spcAft>
-              <a:buNone/>
-            </a:pPr>
-            <a:r>
-              <a:rPr lang="en" sz="750" b="0" i="0">
-                <a:solidFill>
-                  <a:srgbClr val="6B5C45"/>
-                </a:solidFill>
-                <a:latin typeface="Courier New"/>
-                <a:ea typeface="Courier New"/>
-                <a:cs typeface="Courier New"/>
-                <a:sym typeface="Courier New"/>
-              </a:rPr>
-              <a:t>8 / 8</a:t>
+              <a:t>7 / 7</a:t>
             </a:r>
           </a:p>
         </p:txBody>
       </p:sp>
       <p:pic>
         <p:nvPicPr>
-          <p:cNvPr id="31" name="pic31"/>
+          <p:cNvPr id="44" name="pic44"/>
           <p:cNvPicPr preferRelativeResize="0"/>
           <p:nvPr/>
         </p:nvPicPr>

</xml_diff>